<commit_message>
Overview deck: slides 6-7 redrawn in the deck's ACFC chrome for the final architecture (SharePoint/Jira/Confluence connectors, Unity Catalog, the job, review app, Collibra)
Co-Authored-By: Claude Fable 5 <noreply@anthropic.com>
</commit_message>
<xml_diff>
--- a/context/ACFC_AI_in_Engineering_Program_Overview_New Draft.pptx
+++ b/context/ACFC_AI_in_Engineering_Program_Overview_New Draft.pptx
@@ -5,7 +5,7 @@
     <p:sldMasterId id="2147483648" r:id="rId4"/>
   </p:sldMasterIdLst>
   <p:notesMasterIdLst>
-    <p:notesMasterId r:id="rId24"/>
+    <p:notesMasterId r:id="rId21"/>
   </p:notesMasterIdLst>
   <p:sldIdLst>
     <p:sldId id="256" r:id="rId5"/>
@@ -22,11 +22,8 @@
     <p:sldId id="2147469752" r:id="rId16"/>
     <p:sldId id="2147469771" r:id="rId17"/>
     <p:sldId id="264" r:id="rId18"/>
-    <p:sldId id="2147469753" r:id="rId19"/>
-    <p:sldId id="2147469754" r:id="rId20"/>
-    <p:sldId id="2147469768" r:id="rId21"/>
-    <p:sldId id="2147469765" r:id="rId22"/>
-    <p:sldId id="262" r:id="rId23"/>
+    <p:sldId id="2147469765" r:id="rId19"/>
+    <p:sldId id="262" r:id="rId20"/>
   </p:sldIdLst>
   <p:sldSz cx="12192000" cy="6858000"/>
   <p:notesSz cx="6858000" cy="12192000"/>
@@ -141,9 +138,6 @@
             <p14:sldId id="2147469752"/>
             <p14:sldId id="2147469771"/>
             <p14:sldId id="264"/>
-            <p14:sldId id="2147469753"/>
-            <p14:sldId id="2147469754"/>
-            <p14:sldId id="2147469768"/>
             <p14:sldId id="2147469765"/>
             <p14:sldId id="262"/>
           </p14:sldIdLst>
@@ -160,6 +154,7 @@
 <file path=ppt/revisionInfo.xml><?xml version="1.0" encoding="utf-8"?>
 <p1510:revInfo xmlns:a="http://schemas.openxmlformats.org/drawingml/2006/main" xmlns:r="http://schemas.openxmlformats.org/officeDocument/2006/relationships" xmlns:p1510="http://schemas.microsoft.com/office/powerpoint/2015/10/main">
   <p1510:revLst>
+    <p1510:client id="{0FAF1090-E779-9589-53C0-BCE84208D3B8}" v="1" dt="2026-08-27T20:42:20.873"/>
     <p1510:client id="{56F99941-40A3-47CB-9BE5-F9F0FA358D8C}" v="787" dt="2026-08-27T11:28:20.765"/>
     <p1510:client id="{B5C27B78-DEAE-4E4F-9BBA-7105430FE859}" v="714" dt="2026-08-27T12:09:56.239"/>
   </p1510:revLst>
@@ -247,7 +242,7 @@
           </a:lstStyle>
           <a:p>
             <a:fld id="{8BB7AAE9-E3B9-4C1F-B063-B56A918B35C1}" type="datetimeFigureOut">
-              <a:t>8/27/2026</a:t>
+              <a:t>8/28/2026</a:t>
             </a:fld>
             <a:endParaRPr lang="en-US"/>
           </a:p>
@@ -558,7 +553,7 @@
           <a:lstStyle/>
           <a:p>
             <a:r>
-              <a:rPr lang="en-US" dirty="0"/>
+              <a:rPr lang="en-US"/>
               <a:t>ACFC-formatted program overview. Architecture slides depict the target shape inside AmeriHealth's own Databricks account.</a:t>
             </a:r>
           </a:p>
@@ -645,7 +640,7 @@
           <a:lstStyle/>
           <a:p>
             <a:r>
-              <a:rPr lang="en-US" dirty="0"/>
+              <a:rPr lang="en-US"/>
               <a:t>Two-layer trust rule: templates write code; the model only advises on rules templates cannot cover.</a:t>
             </a:r>
           </a:p>
@@ -749,7 +744,7 @@
           <a:bodyPr/>
           <a:lstStyle/>
           <a:p>
-            <a:endParaRPr lang="en-US" dirty="0"/>
+            <a:endParaRPr lang="en-US"/>
           </a:p>
         </p:txBody>
       </p:sp>
@@ -839,7 +834,7 @@
           <a:bodyPr/>
           <a:lstStyle/>
           <a:p>
-            <a:endParaRPr lang="en-US" dirty="0"/>
+            <a:endParaRPr lang="en-US"/>
           </a:p>
         </p:txBody>
       </p:sp>
@@ -884,114 +879,6 @@
   <p:cSld>
     <p:spTree>
       <p:nvGrpSpPr>
-        <p:cNvPr id="1" name="">
-          <a:extLst>
-            <a:ext uri="{FF2B5EF4-FFF2-40B4-BE49-F238E27FC236}">
-              <a16:creationId xmlns:a16="http://schemas.microsoft.com/office/drawing/2014/main" id="{C6670B91-F058-E17E-E7F9-AD135EF13B7C}"/>
-            </a:ext>
-          </a:extLst>
-        </p:cNvPr>
-        <p:cNvGrpSpPr/>
-        <p:nvPr/>
-      </p:nvGrpSpPr>
-      <p:grpSpPr>
-        <a:xfrm>
-          <a:off x="0" y="0"/>
-          <a:ext cx="0" cy="0"/>
-          <a:chOff x="0" y="0"/>
-          <a:chExt cx="0" cy="0"/>
-        </a:xfrm>
-      </p:grpSpPr>
-      <p:sp>
-        <p:nvSpPr>
-          <p:cNvPr id="2" name="Slide Image Placeholder 1">
-            <a:extLst>
-              <a:ext uri="{FF2B5EF4-FFF2-40B4-BE49-F238E27FC236}">
-                <a16:creationId xmlns:a16="http://schemas.microsoft.com/office/drawing/2014/main" id="{8EC31B48-F3AB-130F-8093-444EE92B6ADB}"/>
-              </a:ext>
-            </a:extLst>
-          </p:cNvPr>
-          <p:cNvSpPr>
-            <a:spLocks noGrp="1" noRot="1" noChangeAspect="1"/>
-          </p:cNvSpPr>
-          <p:nvPr>
-            <p:ph type="sldImg"/>
-          </p:nvPr>
-        </p:nvSpPr>
-        <p:spPr/>
-      </p:sp>
-      <p:sp>
-        <p:nvSpPr>
-          <p:cNvPr id="3" name="Notes Placeholder 2">
-            <a:extLst>
-              <a:ext uri="{FF2B5EF4-FFF2-40B4-BE49-F238E27FC236}">
-                <a16:creationId xmlns:a16="http://schemas.microsoft.com/office/drawing/2014/main" id="{6079E167-ED03-9A6D-E11D-27A5C2BA2AAB}"/>
-              </a:ext>
-            </a:extLst>
-          </p:cNvPr>
-          <p:cNvSpPr>
-            <a:spLocks noGrp="1"/>
-          </p:cNvSpPr>
-          <p:nvPr>
-            <p:ph type="body" idx="1"/>
-          </p:nvPr>
-        </p:nvSpPr>
-        <p:spPr/>
-        <p:txBody>
-          <a:bodyPr/>
-          <a:lstStyle/>
-          <a:p>
-            <a:endParaRPr lang="en-US"/>
-          </a:p>
-        </p:txBody>
-      </p:sp>
-      <p:sp>
-        <p:nvSpPr>
-          <p:cNvPr id="4" name="Slide Number Placeholder 3">
-            <a:extLst>
-              <a:ext uri="{FF2B5EF4-FFF2-40B4-BE49-F238E27FC236}">
-                <a16:creationId xmlns:a16="http://schemas.microsoft.com/office/drawing/2014/main" id="{98F7DCBC-918F-1FA7-407B-C7543F65F79F}"/>
-              </a:ext>
-            </a:extLst>
-          </p:cNvPr>
-          <p:cNvSpPr>
-            <a:spLocks noGrp="1"/>
-          </p:cNvSpPr>
-          <p:nvPr>
-            <p:ph type="sldNum" sz="quarter" idx="10"/>
-          </p:nvPr>
-        </p:nvSpPr>
-        <p:spPr/>
-        <p:txBody>
-          <a:bodyPr/>
-          <a:lstStyle/>
-          <a:p>
-            <a:fld id="{F7021451-1387-4CA6-816F-3879F97B5CBC}" type="slidenum">
-              <a:rPr lang="en-US"/>
-              <a:t>17</a:t>
-            </a:fld>
-            <a:endParaRPr lang="en-US"/>
-          </a:p>
-        </p:txBody>
-      </p:sp>
-    </p:spTree>
-    <p:extLst>
-      <p:ext uri="{BB962C8B-B14F-4D97-AF65-F5344CB8AC3E}">
-        <p14:creationId xmlns:p14="http://schemas.microsoft.com/office/powerpoint/2010/main" val="3396255336"/>
-      </p:ext>
-    </p:extLst>
-  </p:cSld>
-  <p:clrMapOvr>
-    <a:masterClrMapping/>
-  </p:clrMapOvr>
-</p:notes>
-</file>
-
-<file path=ppt/notesSlides/notesSlide14.xml><?xml version="1.0" encoding="utf-8"?>
-<p:notes xmlns:a="http://schemas.openxmlformats.org/drawingml/2006/main" xmlns:r="http://schemas.openxmlformats.org/officeDocument/2006/relationships" xmlns:p="http://schemas.openxmlformats.org/presentationml/2006/main">
-  <p:cSld>
-    <p:spTree>
-      <p:nvGrpSpPr>
         <p:cNvPr id="1" name=""/>
         <p:cNvGrpSpPr/>
         <p:nvPr/>
@@ -1031,7 +918,7 @@
           <a:bodyPr/>
           <a:lstStyle/>
           <a:p>
-            <a:endParaRPr lang="en-US" dirty="0"/>
+            <a:endParaRPr lang="en-US"/>
           </a:p>
         </p:txBody>
       </p:sp>
@@ -1052,7 +939,7 @@
           <a:p>
             <a:fld id="{F7021451-1387-4CA6-816F-3879F97B5CBC}" type="slidenum">
               <a:rPr lang="en-US"/>
-              <a:t>19</a:t>
+              <a:t>16</a:t>
             </a:fld>
             <a:endParaRPr lang="en-US"/>
           </a:p>
@@ -1115,7 +1002,7 @@
           <a:bodyPr/>
           <a:lstStyle/>
           <a:p>
-            <a:endParaRPr lang="en-US" dirty="0"/>
+            <a:endParaRPr lang="en-US"/>
           </a:p>
         </p:txBody>
       </p:sp>
@@ -1217,7 +1104,7 @@
           <a:bodyPr/>
           <a:lstStyle/>
           <a:p>
-            <a:endParaRPr lang="en-US" dirty="0"/>
+            <a:endParaRPr lang="en-US"/>
           </a:p>
         </p:txBody>
       </p:sp>
@@ -1325,7 +1212,7 @@
           <a:bodyPr/>
           <a:lstStyle/>
           <a:p>
-            <a:endParaRPr lang="en-US" dirty="0"/>
+            <a:endParaRPr lang="en-US"/>
           </a:p>
         </p:txBody>
       </p:sp>
@@ -1415,7 +1302,7 @@
           <a:bodyPr/>
           <a:lstStyle/>
           <a:p>
-            <a:endParaRPr lang="en-US" dirty="0"/>
+            <a:endParaRPr lang="en-US"/>
           </a:p>
         </p:txBody>
       </p:sp>
@@ -1517,7 +1404,7 @@
           <a:bodyPr/>
           <a:lstStyle/>
           <a:p>
-            <a:endParaRPr lang="en-US" dirty="0"/>
+            <a:endParaRPr lang="en-US"/>
           </a:p>
         </p:txBody>
       </p:sp>
@@ -1625,7 +1512,7 @@
           <a:bodyPr/>
           <a:lstStyle/>
           <a:p>
-            <a:endParaRPr lang="en-US" dirty="0"/>
+            <a:endParaRPr lang="en-US"/>
           </a:p>
         </p:txBody>
       </p:sp>
@@ -1733,7 +1620,7 @@
           <a:bodyPr/>
           <a:lstStyle/>
           <a:p>
-            <a:endParaRPr lang="en-US" dirty="0"/>
+            <a:endParaRPr lang="en-US"/>
           </a:p>
         </p:txBody>
       </p:sp>
@@ -1901,7 +1788,7 @@
           <a:bodyPr/>
           <a:lstStyle/>
           <a:p>
-            <a:endParaRPr lang="en-US" dirty="0"/>
+            <a:endParaRPr lang="en-US"/>
           </a:p>
         </p:txBody>
       </p:sp>
@@ -2011,7 +1898,7 @@
           <a:p>
             <a:fld id="{5BCAD085-E8A6-8845-BD4E-CB4CCA059FC4}" type="datetimeFigureOut">
               <a:rPr lang="en-US" smtClean="0"/>
-              <a:t>8/27/2026</a:t>
+              <a:t>8/28/2026</a:t>
             </a:fld>
             <a:endParaRPr lang="en-US"/>
           </a:p>
@@ -2469,7 +2356,7 @@
               <a:buNone/>
             </a:pPr>
             <a:r>
-              <a:rPr lang="en-US" sz="1100" b="1" kern="0" spc="300" dirty="0">
+              <a:rPr lang="en-US" sz="1100" b="1" kern="0" spc="300">
                 <a:solidFill>
                   <a:srgbClr val="FFFFFF"/>
                 </a:solidFill>
@@ -2479,7 +2366,7 @@
               </a:rPr>
               <a:t>AGENTIC AI  |  DATA ENGINEERING</a:t>
             </a:r>
-            <a:endParaRPr lang="en-US" sz="1100" dirty="0"/>
+            <a:endParaRPr lang="en-US" sz="1100"/>
           </a:p>
         </p:txBody>
       </p:sp>
@@ -2508,7 +2395,7 @@
               <a:buNone/>
             </a:pPr>
             <a:r>
-              <a:rPr lang="en-US" sz="4000" b="1" dirty="0">
+              <a:rPr lang="en-US" sz="4000" b="1">
                 <a:solidFill>
                   <a:srgbClr val="FFFFFF"/>
                 </a:solidFill>
@@ -2518,7 +2405,7 @@
               </a:rPr>
               <a:t>The AI-in-Data Engineering Program</a:t>
             </a:r>
-            <a:endParaRPr lang="en-US" sz="4000" dirty="0"/>
+            <a:endParaRPr lang="en-US" sz="4000"/>
           </a:p>
         </p:txBody>
       </p:sp>
@@ -2547,7 +2434,7 @@
               <a:buNone/>
             </a:pPr>
             <a:r>
-              <a:rPr lang="en-US" sz="1700" dirty="0">
+              <a:rPr lang="en-US" sz="1700">
                 <a:solidFill>
                   <a:srgbClr val="FFFFFF"/>
                 </a:solidFill>
@@ -2557,7 +2444,7 @@
               </a:rPr>
               <a:t>Program Overview  ·  the two agents, end to end</a:t>
             </a:r>
-            <a:endParaRPr lang="en-US" sz="1700" dirty="0"/>
+            <a:endParaRPr lang="en-US" sz="1700"/>
           </a:p>
         </p:txBody>
       </p:sp>
@@ -2586,7 +2473,7 @@
               <a:buNone/>
             </a:pPr>
             <a:r>
-              <a:rPr lang="en-US" sz="1300" i="1" dirty="0">
+              <a:rPr lang="en-US" sz="1300" i="1">
                 <a:solidFill>
                   <a:srgbClr val="FFFFFF"/>
                 </a:solidFill>
@@ -2596,14 +2483,14 @@
               </a:rPr>
               <a:t>Two agents on one governed</a:t>
             </a:r>
-            <a:endParaRPr lang="en-US" sz="1300" dirty="0"/>
+            <a:endParaRPr lang="en-US" sz="1300"/>
           </a:p>
           <a:p>
             <a:pPr marL="0" indent="0" algn="r">
               <a:buNone/>
             </a:pPr>
             <a:r>
-              <a:rPr lang="en-US" sz="1300" i="1" dirty="0">
+              <a:rPr lang="en-US" sz="1300" i="1">
                 <a:solidFill>
                   <a:srgbClr val="FFFFFF"/>
                 </a:solidFill>
@@ -2613,7 +2500,7 @@
               </a:rPr>
               <a:t>Databricks platform</a:t>
             </a:r>
-            <a:endParaRPr lang="en-US" sz="1300" dirty="0"/>
+            <a:endParaRPr lang="en-US" sz="1300"/>
           </a:p>
         </p:txBody>
       </p:sp>
@@ -2642,7 +2529,7 @@
               <a:buNone/>
             </a:pPr>
             <a:r>
-              <a:rPr lang="en-US" sz="1200" dirty="0">
+              <a:rPr lang="en-US" sz="1200">
                 <a:solidFill>
                   <a:srgbClr val="FFFFFF"/>
                 </a:solidFill>
@@ -2652,7 +2539,7 @@
               </a:rPr>
               <a:t>August 2026</a:t>
             </a:r>
-            <a:endParaRPr lang="en-US" sz="1200" dirty="0"/>
+            <a:endParaRPr lang="en-US" sz="1200"/>
           </a:p>
         </p:txBody>
       </p:sp>
@@ -2681,7 +2568,7 @@
               <a:buNone/>
             </a:pPr>
             <a:r>
-              <a:rPr lang="en-US" sz="800" dirty="0">
+              <a:rPr lang="en-US" sz="800">
                 <a:solidFill>
                   <a:srgbClr val="CFE0EE"/>
                 </a:solidFill>
@@ -2691,7 +2578,7 @@
               </a:rPr>
               <a:t>Proprietary and Confidential</a:t>
             </a:r>
-            <a:endParaRPr lang="en-US" sz="800" dirty="0"/>
+            <a:endParaRPr lang="en-US" sz="800"/>
           </a:p>
         </p:txBody>
       </p:sp>
@@ -2771,7 +2658,7 @@
               <a:buNone/>
             </a:pPr>
             <a:r>
-              <a:rPr lang="en-US" sz="2000" b="1" dirty="0" err="1">
+              <a:rPr lang="en-US" sz="2000" b="1" err="1">
                 <a:solidFill>
                   <a:srgbClr val="FFFFFF"/>
                 </a:solidFill>
@@ -2782,7 +2669,7 @@
               <a:t>CodeGen</a:t>
             </a:r>
             <a:r>
-              <a:rPr lang="en-US" sz="2000" b="1" dirty="0">
+              <a:rPr lang="en-US" sz="2000" b="1">
                 <a:solidFill>
                   <a:srgbClr val="FFFFFF"/>
                 </a:solidFill>
@@ -2792,7 +2679,7 @@
               </a:rPr>
               <a:t> Agent Architecture</a:t>
             </a:r>
-            <a:endParaRPr lang="en-US" sz="2000" dirty="0"/>
+            <a:endParaRPr lang="en-US" sz="2000"/>
           </a:p>
         </p:txBody>
       </p:sp>
@@ -2827,7 +2714,7 @@
               <a:buNone/>
             </a:pPr>
             <a:r>
-              <a:rPr lang="en-US" sz="800" dirty="0">
+              <a:rPr lang="en-US" sz="800">
                 <a:solidFill>
                   <a:srgbClr val="9AA5AE"/>
                 </a:solidFill>
@@ -2837,7 +2724,7 @@
               </a:rPr>
               <a:t>2</a:t>
             </a:r>
-            <a:endParaRPr lang="en-US" sz="800" dirty="0"/>
+            <a:endParaRPr lang="en-US" sz="800"/>
           </a:p>
         </p:txBody>
       </p:sp>
@@ -2878,7 +2765,7 @@
               <a:buNone/>
             </a:pPr>
             <a:r>
-              <a:rPr lang="en-US" sz="1200" dirty="0">
+              <a:rPr lang="en-US" sz="1200">
                 <a:solidFill>
                   <a:schemeClr val="bg1"/>
                 </a:solidFill>
@@ -2888,7 +2775,7 @@
               </a:rPr>
               <a:t>     The approved STTM becomes deployable artefacts — a PySpark notebook, or DDL and SQL for the existing ingestion framework</a:t>
             </a:r>
-            <a:endParaRPr lang="en-US" sz="1200" dirty="0">
+            <a:endParaRPr lang="en-US" sz="1200">
               <a:solidFill>
                 <a:schemeClr val="bg1"/>
               </a:solidFill>
@@ -3823,9 +3710,9 @@
           <p:nvPr/>
         </p:nvSpPr>
         <p:spPr>
-          <a:xfrm>
-            <a:off x="9952692" y="3982948"/>
-            <a:ext cx="100584" cy="100584"/>
+          <a:xfrm flipV="1">
+            <a:off x="9952692" y="4083532"/>
+            <a:ext cx="50285" cy="59436"/>
           </a:xfrm>
           <a:prstGeom prst="ellipse">
             <a:avLst/>
@@ -4117,7 +4004,7 @@
               <a:buNone/>
             </a:pPr>
             <a:r>
-              <a:rPr lang="en-US" sz="1150" b="1" dirty="0">
+              <a:rPr lang="en-US" sz="1150" b="1">
                 <a:solidFill>
                   <a:srgbClr val="FFFFFF"/>
                 </a:solidFill>
@@ -4127,7 +4014,7 @@
               </a:rPr>
               <a:t>Engineer starts a run</a:t>
             </a:r>
-            <a:endParaRPr lang="en-US" sz="1150" dirty="0"/>
+            <a:endParaRPr lang="en-US" sz="1150"/>
           </a:p>
         </p:txBody>
       </p:sp>
@@ -4162,7 +4049,7 @@
               <a:buNone/>
             </a:pPr>
             <a:r>
-              <a:rPr lang="en-US" sz="850" dirty="0">
+              <a:rPr lang="en-US" sz="850">
                 <a:solidFill>
                   <a:srgbClr val="D4E7FF"/>
                 </a:solidFill>
@@ -4172,7 +4059,7 @@
               </a:rPr>
               <a:t>Databricks app · one approved STTM per run</a:t>
             </a:r>
-            <a:endParaRPr lang="en-US" sz="850" dirty="0"/>
+            <a:endParaRPr lang="en-US" sz="850"/>
           </a:p>
         </p:txBody>
       </p:sp>
@@ -4207,7 +4094,7 @@
               <a:buNone/>
             </a:pPr>
             <a:r>
-              <a:rPr lang="en-US" sz="950" b="1" kern="0" spc="120" dirty="0">
+              <a:rPr lang="en-US" sz="950" b="1" kern="0" spc="120">
                 <a:solidFill>
                   <a:srgbClr val="3C2CDA"/>
                 </a:solidFill>
@@ -4217,7 +4104,7 @@
               </a:rPr>
               <a:t>SOURCE INPUTS</a:t>
             </a:r>
-            <a:endParaRPr lang="en-US" sz="950" dirty="0"/>
+            <a:endParaRPr lang="en-US" sz="950"/>
           </a:p>
         </p:txBody>
       </p:sp>
@@ -4322,7 +4209,7 @@
               <a:buNone/>
             </a:pPr>
             <a:r>
-              <a:rPr lang="en-US" sz="1050" b="1" dirty="0">
+              <a:rPr lang="en-US" sz="1050" b="1">
                 <a:solidFill>
                   <a:srgbClr val="1A1D2E"/>
                 </a:solidFill>
@@ -4332,7 +4219,7 @@
               </a:rPr>
               <a:t>Approved STTM, FRD</a:t>
             </a:r>
-            <a:endParaRPr lang="en-US" sz="1050" dirty="0"/>
+            <a:endParaRPr lang="en-US" sz="1050"/>
           </a:p>
         </p:txBody>
       </p:sp>
@@ -4367,7 +4254,7 @@
               <a:buNone/>
             </a:pPr>
             <a:r>
-              <a:rPr lang="en-US" sz="760" dirty="0">
+              <a:rPr lang="en-US" sz="760">
                 <a:solidFill>
                   <a:srgbClr val="6B7188"/>
                 </a:solidFill>
@@ -4377,7 +4264,7 @@
               </a:rPr>
               <a:t>Signed-off mapping from the STTM agent</a:t>
             </a:r>
-            <a:endParaRPr lang="en-US" sz="760" dirty="0"/>
+            <a:endParaRPr lang="en-US" sz="760"/>
           </a:p>
         </p:txBody>
       </p:sp>
@@ -4515,7 +4402,7 @@
               <a:buNone/>
             </a:pPr>
             <a:r>
-              <a:rPr lang="en-US" sz="1050" b="1" dirty="0">
+              <a:rPr lang="en-US" sz="1050" b="1">
                 <a:solidFill>
                   <a:srgbClr val="1A1D2E"/>
                 </a:solidFill>
@@ -4525,7 +4412,7 @@
               </a:rPr>
               <a:t>Data Structures</a:t>
             </a:r>
-            <a:endParaRPr lang="en-US" sz="1050" dirty="0"/>
+            <a:endParaRPr lang="en-US" sz="1050"/>
           </a:p>
         </p:txBody>
       </p:sp>
@@ -4560,7 +4447,7 @@
               <a:buNone/>
             </a:pPr>
             <a:r>
-              <a:rPr lang="en-US" sz="760" dirty="0">
+              <a:rPr lang="en-US" sz="760">
                 <a:solidFill>
                   <a:srgbClr val="6B7188"/>
                 </a:solidFill>
@@ -4570,7 +4457,7 @@
               </a:rPr>
               <a:t>Target schemas, DDL &amp; naming standards</a:t>
             </a:r>
-            <a:endParaRPr lang="en-US" sz="760" dirty="0"/>
+            <a:endParaRPr lang="en-US" sz="760"/>
           </a:p>
         </p:txBody>
       </p:sp>
@@ -4678,7 +4565,7 @@
               <a:buNone/>
             </a:pPr>
             <a:r>
-              <a:rPr lang="en-US" sz="1050" b="1" dirty="0">
+              <a:rPr lang="en-US" sz="1050" b="1">
                 <a:solidFill>
                   <a:srgbClr val="1A1D2E"/>
                 </a:solidFill>
@@ -4688,7 +4575,7 @@
               </a:rPr>
               <a:t>Collibra</a:t>
             </a:r>
-            <a:endParaRPr lang="en-US" sz="1050" dirty="0"/>
+            <a:endParaRPr lang="en-US" sz="1050"/>
           </a:p>
         </p:txBody>
       </p:sp>
@@ -4723,7 +4610,7 @@
               <a:buNone/>
             </a:pPr>
             <a:r>
-              <a:rPr lang="en-US" sz="760" dirty="0">
+              <a:rPr lang="en-US" sz="760">
                 <a:solidFill>
                   <a:srgbClr val="6B7188"/>
                 </a:solidFill>
@@ -4733,7 +4620,7 @@
               </a:rPr>
               <a:t>Glossary, classifications &amp; data policies</a:t>
             </a:r>
-            <a:endParaRPr lang="en-US" sz="760" dirty="0"/>
+            <a:endParaRPr lang="en-US" sz="760"/>
           </a:p>
         </p:txBody>
       </p:sp>
@@ -4909,7 +4796,7 @@
                 <a:ea typeface="Calibri" pitchFamily="34" charset="-122"/>
                 <a:cs typeface="Calibri" pitchFamily="34" charset="-120"/>
               </a:rPr>
-              <a:t>Reference code library</a:t>
+              <a:t>Reference library</a:t>
             </a:r>
             <a:endParaRPr lang="en-US" sz="880" dirty="0"/>
           </a:p>
@@ -4954,7 +4841,7 @@
                 <a:ea typeface="Calibri" pitchFamily="34" charset="-122"/>
                 <a:cs typeface="Calibri" pitchFamily="34" charset="-120"/>
               </a:rPr>
-              <a:t>Merged pipelines ground future generations</a:t>
+              <a:t>Naming and coding standards, sample notebooks</a:t>
             </a:r>
             <a:endParaRPr lang="en-US" sz="720" dirty="0"/>
           </a:p>
@@ -5094,7 +4981,7 @@
               <a:buNone/>
             </a:pPr>
             <a:r>
-              <a:rPr lang="en-US" sz="900" b="1" dirty="0">
+              <a:rPr lang="en-US" sz="900" b="1">
                 <a:solidFill>
                   <a:srgbClr val="07125E"/>
                 </a:solidFill>
@@ -5104,7 +4991,7 @@
               </a:rPr>
               <a:t>Connector layer</a:t>
             </a:r>
-            <a:endParaRPr lang="en-US" sz="900" dirty="0"/>
+            <a:endParaRPr lang="en-US" sz="900"/>
           </a:p>
         </p:txBody>
       </p:sp>
@@ -5139,7 +5026,7 @@
               <a:buNone/>
             </a:pPr>
             <a:r>
-              <a:rPr lang="en-US" sz="720" dirty="0">
+              <a:rPr lang="en-US" sz="720">
                 <a:solidFill>
                   <a:srgbClr val="6B7188"/>
                 </a:solidFill>
@@ -5149,7 +5036,7 @@
               </a:rPr>
               <a:t>MCP services expose each system through one pattern</a:t>
             </a:r>
-            <a:endParaRPr lang="en-US" sz="720" dirty="0"/>
+            <a:endParaRPr lang="en-US" sz="720"/>
           </a:p>
         </p:txBody>
       </p:sp>
@@ -5280,7 +5167,7 @@
               <a:buNone/>
             </a:pPr>
             <a:r>
-              <a:rPr lang="en-US" sz="1300" b="1" dirty="0">
+              <a:rPr lang="en-US" sz="1300" b="1">
                 <a:solidFill>
                   <a:srgbClr val="FFFFFF"/>
                 </a:solidFill>
@@ -5290,7 +5177,7 @@
               </a:rPr>
               <a:t>CodeGen Agent</a:t>
             </a:r>
-            <a:endParaRPr lang="en-US" sz="1300" dirty="0"/>
+            <a:endParaRPr lang="en-US" sz="1300"/>
           </a:p>
         </p:txBody>
       </p:sp>
@@ -5325,7 +5212,7 @@
               <a:buNone/>
             </a:pPr>
             <a:r>
-              <a:rPr lang="en-US" sz="820" dirty="0">
+              <a:rPr lang="en-US" sz="820">
                 <a:solidFill>
                   <a:srgbClr val="D6D2F7"/>
                 </a:solidFill>
@@ -5335,14 +5222,14 @@
               </a:rPr>
               <a:t>Databricks serverless job</a:t>
             </a:r>
-            <a:endParaRPr lang="en-US" sz="820" dirty="0"/>
+            <a:endParaRPr lang="en-US" sz="820"/>
           </a:p>
           <a:p>
             <a:pPr marL="0" indent="0" algn="ctr">
               <a:buNone/>
             </a:pPr>
             <a:r>
-              <a:rPr lang="en-US" sz="820" dirty="0">
+              <a:rPr lang="en-US" sz="820">
                 <a:solidFill>
                   <a:srgbClr val="D6D2F7"/>
                 </a:solidFill>
@@ -5352,7 +5239,7 @@
               </a:rPr>
               <a:t>four stages · one model call</a:t>
             </a:r>
-            <a:endParaRPr lang="en-US" sz="820" dirty="0"/>
+            <a:endParaRPr lang="en-US" sz="820"/>
           </a:p>
         </p:txBody>
       </p:sp>
@@ -5422,7 +5309,7 @@
               <a:buNone/>
             </a:pPr>
             <a:r>
-              <a:rPr lang="en-US" sz="760" b="1" dirty="0">
+              <a:rPr lang="en-US" sz="760" b="1">
                 <a:solidFill>
                   <a:srgbClr val="07125E"/>
                 </a:solidFill>
@@ -5432,7 +5319,7 @@
               </a:rPr>
               <a:t>Ingest</a:t>
             </a:r>
-            <a:endParaRPr lang="en-US" sz="760" dirty="0"/>
+            <a:endParaRPr lang="en-US" sz="760"/>
           </a:p>
         </p:txBody>
       </p:sp>
@@ -5502,7 +5389,7 @@
               <a:buNone/>
             </a:pPr>
             <a:r>
-              <a:rPr lang="en-US" sz="760" b="1" dirty="0">
+              <a:rPr lang="en-US" sz="760" b="1">
                 <a:solidFill>
                   <a:srgbClr val="07125E"/>
                 </a:solidFill>
@@ -5512,7 +5399,7 @@
               </a:rPr>
               <a:t>Generate</a:t>
             </a:r>
-            <a:endParaRPr lang="en-US" sz="760" dirty="0"/>
+            <a:endParaRPr lang="en-US" sz="760"/>
           </a:p>
         </p:txBody>
       </p:sp>
@@ -5582,7 +5469,7 @@
               <a:buNone/>
             </a:pPr>
             <a:r>
-              <a:rPr lang="en-US" sz="760" b="1" dirty="0">
+              <a:rPr lang="en-US" sz="760" b="1">
                 <a:solidFill>
                   <a:srgbClr val="14CBDE"/>
                 </a:solidFill>
@@ -5592,7 +5479,7 @@
               </a:rPr>
               <a:t>Test · Gate</a:t>
             </a:r>
-            <a:endParaRPr lang="en-US" sz="760" dirty="0"/>
+            <a:endParaRPr lang="en-US" sz="760"/>
           </a:p>
         </p:txBody>
       </p:sp>
@@ -5662,7 +5549,7 @@
               <a:buNone/>
             </a:pPr>
             <a:r>
-              <a:rPr lang="en-US" sz="760" b="1" dirty="0">
+              <a:rPr lang="en-US" sz="760" b="1">
                 <a:solidFill>
                   <a:srgbClr val="07125E"/>
                 </a:solidFill>
@@ -5672,7 +5559,7 @@
               </a:rPr>
               <a:t>Package</a:t>
             </a:r>
-            <a:endParaRPr lang="en-US" sz="760" dirty="0"/>
+            <a:endParaRPr lang="en-US" sz="760"/>
           </a:p>
         </p:txBody>
       </p:sp>
@@ -5707,7 +5594,7 @@
               <a:buNone/>
             </a:pPr>
             <a:r>
-              <a:rPr lang="en-US" sz="950" b="1" kern="0" spc="120" dirty="0">
+              <a:rPr lang="en-US" sz="950" b="1" kern="0" spc="120">
                 <a:solidFill>
                   <a:srgbClr val="3C2CDA"/>
                 </a:solidFill>
@@ -5717,7 +5604,7 @@
               </a:rPr>
               <a:t>GENERATED  ·  DRAFT</a:t>
             </a:r>
-            <a:endParaRPr lang="en-US" sz="950" dirty="0"/>
+            <a:endParaRPr lang="en-US" sz="950"/>
           </a:p>
         </p:txBody>
       </p:sp>
@@ -5736,7 +5623,7 @@
         <p:spPr>
           <a:xfrm>
             <a:off x="8539944" y="1674088"/>
-            <a:ext cx="2926080" cy="2331720"/>
+            <a:ext cx="2926080" cy="2862072"/>
           </a:xfrm>
           <a:prstGeom prst="roundRect">
             <a:avLst>
@@ -5792,7 +5679,7 @@
               <a:buNone/>
             </a:pPr>
             <a:r>
-              <a:rPr lang="en-US" sz="700" b="1" kern="0" spc="80" dirty="0">
+              <a:rPr lang="en-US" sz="700" b="1" kern="0" spc="80">
                 <a:solidFill>
                   <a:srgbClr val="6B7188"/>
                 </a:solidFill>
@@ -5802,7 +5689,7 @@
               </a:rPr>
               <a:t>OPTION A  ·  NOTEBOOK</a:t>
             </a:r>
-            <a:endParaRPr lang="en-US" sz="700" dirty="0"/>
+            <a:endParaRPr lang="en-US" sz="700"/>
           </a:p>
         </p:txBody>
       </p:sp>
@@ -5952,7 +5839,7 @@
               <a:buNone/>
             </a:pPr>
             <a:r>
-              <a:rPr lang="en-US" sz="720" dirty="0">
+              <a:rPr lang="en-US" sz="720">
                 <a:solidFill>
                   <a:srgbClr val="6B7188"/>
                 </a:solidFill>
@@ -5962,7 +5849,7 @@
               </a:rPr>
               <a:t>Runs natively on Databricks</a:t>
             </a:r>
-            <a:endParaRPr lang="en-US" sz="720" dirty="0"/>
+            <a:endParaRPr lang="en-US" sz="720"/>
           </a:p>
         </p:txBody>
       </p:sp>
@@ -6033,7 +5920,7 @@
               <a:buNone/>
             </a:pPr>
             <a:r>
-              <a:rPr lang="en-US" sz="800" i="1" dirty="0">
+              <a:rPr lang="en-US" sz="800" i="1">
                 <a:solidFill>
                   <a:srgbClr val="6B7188"/>
                 </a:solidFill>
@@ -6043,7 +5930,7 @@
               </a:rPr>
               <a:t>or</a:t>
             </a:r>
-            <a:endParaRPr lang="en-US" sz="800" dirty="0"/>
+            <a:endParaRPr lang="en-US" sz="800"/>
           </a:p>
         </p:txBody>
       </p:sp>
@@ -6114,7 +6001,7 @@
               <a:buNone/>
             </a:pPr>
             <a:r>
-              <a:rPr lang="en-US" sz="700" b="1" kern="0" spc="80" dirty="0">
+              <a:rPr lang="en-US" sz="700" b="1" kern="0" spc="80">
                 <a:solidFill>
                   <a:srgbClr val="6B7188"/>
                 </a:solidFill>
@@ -6124,7 +6011,7 @@
               </a:rPr>
               <a:t>OPTION B  ·  INGESTION FRAMEWORK</a:t>
             </a:r>
-            <a:endParaRPr lang="en-US" sz="700" dirty="0"/>
+            <a:endParaRPr lang="en-US" sz="700"/>
           </a:p>
         </p:txBody>
       </p:sp>
@@ -6274,7 +6161,7 @@
               <a:buNone/>
             </a:pPr>
             <a:r>
-              <a:rPr lang="en-US" sz="720" dirty="0">
+              <a:rPr lang="en-US" sz="720">
                 <a:solidFill>
                   <a:srgbClr val="6B7188"/>
                 </a:solidFill>
@@ -6284,7 +6171,7 @@
               </a:rPr>
               <a:t>.xlsx · target table definitions</a:t>
             </a:r>
-            <a:endParaRPr lang="en-US" sz="720" dirty="0"/>
+            <a:endParaRPr lang="en-US" sz="720"/>
           </a:p>
         </p:txBody>
       </p:sp>
@@ -6434,7 +6321,7 @@
               <a:buNone/>
             </a:pPr>
             <a:r>
-              <a:rPr lang="en-US" sz="720" dirty="0">
+              <a:rPr lang="en-US" sz="720">
                 <a:solidFill>
                   <a:srgbClr val="6B7188"/>
                 </a:solidFill>
@@ -6444,7 +6331,7 @@
               </a:rPr>
               <a:t>.xlsx · config rows for the framework DB</a:t>
             </a:r>
-            <a:endParaRPr lang="en-US" sz="720" dirty="0"/>
+            <a:endParaRPr lang="en-US" sz="720"/>
           </a:p>
         </p:txBody>
       </p:sp>
@@ -6519,7 +6406,7 @@
               <a:buNone/>
             </a:pPr>
             <a:r>
-              <a:rPr lang="en-US" sz="780" b="1" kern="0" spc="110" dirty="0">
+              <a:rPr lang="en-US" sz="780" b="1" kern="0" spc="110">
                 <a:solidFill>
                   <a:srgbClr val="3C2CDA"/>
                 </a:solidFill>
@@ -6529,7 +6416,7 @@
               </a:rPr>
               <a:t>MODEL ACCESS  ·  GOVERNED RUNTIME</a:t>
             </a:r>
-            <a:endParaRPr lang="en-US" sz="780" dirty="0"/>
+            <a:endParaRPr lang="en-US" sz="780"/>
           </a:p>
         </p:txBody>
       </p:sp>
@@ -6662,7 +6549,7 @@
               <a:buNone/>
             </a:pPr>
             <a:r>
-              <a:rPr lang="en-US" sz="950" b="1" dirty="0">
+              <a:rPr lang="en-US" sz="950" b="1">
                 <a:solidFill>
                   <a:srgbClr val="FFFFFF"/>
                 </a:solidFill>
@@ -6672,7 +6559,7 @@
               </a:rPr>
               <a:t>Unity AI Gateway</a:t>
             </a:r>
-            <a:endParaRPr lang="en-US" sz="950" dirty="0"/>
+            <a:endParaRPr lang="en-US" sz="950"/>
           </a:p>
         </p:txBody>
       </p:sp>
@@ -6707,7 +6594,7 @@
               <a:buNone/>
             </a:pPr>
             <a:r>
-              <a:rPr lang="en-US" sz="760" dirty="0">
+              <a:rPr lang="en-US" sz="760">
                 <a:solidFill>
                   <a:srgbClr val="C7CCEA"/>
                 </a:solidFill>
@@ -6717,7 +6604,7 @@
               </a:rPr>
               <a:t>routing · guardrails · rate limits · cost &amp; audit on every call</a:t>
             </a:r>
-            <a:endParaRPr lang="en-US" sz="760" dirty="0"/>
+            <a:endParaRPr lang="en-US" sz="760"/>
           </a:p>
         </p:txBody>
       </p:sp>
@@ -6855,7 +6742,7 @@
               <a:buNone/>
             </a:pPr>
             <a:r>
-              <a:rPr lang="en-US" sz="860" b="1" dirty="0">
+              <a:rPr lang="en-US" sz="860" b="1">
                 <a:solidFill>
                   <a:srgbClr val="1A1D2E"/>
                 </a:solidFill>
@@ -6865,7 +6752,7 @@
               </a:rPr>
               <a:t>Foundation Model APIs</a:t>
             </a:r>
-            <a:endParaRPr lang="en-US" sz="860" dirty="0"/>
+            <a:endParaRPr lang="en-US" sz="860"/>
           </a:p>
         </p:txBody>
       </p:sp>
@@ -6900,7 +6787,7 @@
               <a:buNone/>
             </a:pPr>
             <a:r>
-              <a:rPr lang="en-US" sz="720" dirty="0">
+              <a:rPr lang="en-US" sz="720">
                 <a:solidFill>
                   <a:srgbClr val="6B7188"/>
                 </a:solidFill>
@@ -6910,7 +6797,7 @@
               </a:rPr>
               <a:t>The one model call — pay per token</a:t>
             </a:r>
-            <a:endParaRPr lang="en-US" sz="720" dirty="0"/>
+            <a:endParaRPr lang="en-US" sz="720"/>
           </a:p>
         </p:txBody>
       </p:sp>
@@ -7015,7 +6902,7 @@
               <a:buNone/>
             </a:pPr>
             <a:r>
-              <a:rPr lang="en-US" sz="860" b="1" dirty="0">
+              <a:rPr lang="en-US" sz="860" b="1">
                 <a:solidFill>
                   <a:srgbClr val="1A1D2E"/>
                 </a:solidFill>
@@ -7025,7 +6912,7 @@
               </a:rPr>
               <a:t>Unity Catalog</a:t>
             </a:r>
-            <a:endParaRPr lang="en-US" sz="860" dirty="0"/>
+            <a:endParaRPr lang="en-US" sz="860"/>
           </a:p>
         </p:txBody>
       </p:sp>
@@ -7060,7 +6947,7 @@
               <a:buNone/>
             </a:pPr>
             <a:r>
-              <a:rPr lang="en-US" sz="720" dirty="0">
+              <a:rPr lang="en-US" sz="720">
                 <a:solidFill>
                   <a:srgbClr val="6B7188"/>
                 </a:solidFill>
@@ -7070,7 +6957,7 @@
               </a:rPr>
               <a:t>Schemas · lineage · run history</a:t>
             </a:r>
-            <a:endParaRPr lang="en-US" sz="720" dirty="0"/>
+            <a:endParaRPr lang="en-US" sz="720"/>
           </a:p>
         </p:txBody>
       </p:sp>
@@ -7344,7 +7231,7 @@
               <a:buNone/>
             </a:pPr>
             <a:r>
-              <a:rPr lang="en-US" sz="1200" b="1" dirty="0">
+              <a:rPr lang="en-US" sz="1200" b="1">
                 <a:solidFill>
                   <a:srgbClr val="FFFFFF"/>
                 </a:solidFill>
@@ -7354,7 +7241,7 @@
               </a:rPr>
               <a:t>Engineering review — the merge gate</a:t>
             </a:r>
-            <a:endParaRPr lang="en-US" sz="1200" dirty="0"/>
+            <a:endParaRPr lang="en-US" sz="1200"/>
           </a:p>
         </p:txBody>
       </p:sp>
@@ -7389,7 +7276,7 @@
               <a:buNone/>
             </a:pPr>
             <a:r>
-              <a:rPr lang="en-US" sz="880" dirty="0">
+              <a:rPr lang="en-US" sz="880">
                 <a:solidFill>
                   <a:srgbClr val="C7CCEA"/>
                 </a:solidFill>
@@ -7399,7 +7286,7 @@
               </a:rPr>
               <a:t>Engineers read the generated code, run it against test data, and approve. Nothing merges unreviewed.</a:t>
             </a:r>
-            <a:endParaRPr lang="en-US" sz="880" dirty="0"/>
+            <a:endParaRPr lang="en-US" sz="880"/>
           </a:p>
         </p:txBody>
       </p:sp>
@@ -7470,7 +7357,7 @@
               <a:buNone/>
             </a:pPr>
             <a:r>
-              <a:rPr lang="en-US" sz="700" b="1" kern="0" spc="100" dirty="0">
+              <a:rPr lang="en-US" sz="700" b="1" kern="0" spc="100">
                 <a:solidFill>
                   <a:srgbClr val="8890BE"/>
                 </a:solidFill>
@@ -7480,7 +7367,7 @@
               </a:rPr>
               <a:t>ON APPROVAL</a:t>
             </a:r>
-            <a:endParaRPr lang="en-US" sz="700" dirty="0"/>
+            <a:endParaRPr lang="en-US" sz="700"/>
           </a:p>
         </p:txBody>
       </p:sp>
@@ -7578,7 +7465,7 @@
               <a:buNone/>
             </a:pPr>
             <a:r>
-              <a:rPr lang="en-US" sz="860" dirty="0">
+              <a:rPr lang="en-US" sz="860">
                 <a:solidFill>
                   <a:srgbClr val="14CBDE"/>
                 </a:solidFill>
@@ -7588,7 +7475,7 @@
               </a:rPr>
               <a:t>Notebook merged to the repo via pull request — usual SDLC controls</a:t>
             </a:r>
-            <a:endParaRPr lang="en-US" sz="860" dirty="0"/>
+            <a:endParaRPr lang="en-US" sz="860"/>
           </a:p>
         </p:txBody>
       </p:sp>
@@ -7726,7 +7613,7 @@
               <a:buNone/>
             </a:pPr>
             <a:r>
-              <a:rPr lang="en-US" sz="820" dirty="0">
+              <a:rPr lang="en-US" sz="820">
                 <a:solidFill>
                   <a:srgbClr val="C7CCEA"/>
                 </a:solidFill>
@@ -7736,7 +7623,7 @@
               </a:rPr>
               <a:t>DDL &amp; SQL loaded into the existing ingestion framework database</a:t>
             </a:r>
-            <a:endParaRPr lang="en-US" sz="820" dirty="0"/>
+            <a:endParaRPr lang="en-US" sz="820"/>
           </a:p>
         </p:txBody>
       </p:sp>
@@ -7770,6 +7657,126 @@
           </a:prstGeom>
         </p:spPr>
       </p:pic>
+      <p:pic>
+        <p:nvPicPr>
+          <p:cNvPr id="5" name="Image 8" descr="/home/claude/sttm/logos/databricks.png">
+            <a:extLst>
+              <a:ext uri="{FF2B5EF4-FFF2-40B4-BE49-F238E27FC236}">
+                <a16:creationId xmlns:a16="http://schemas.microsoft.com/office/drawing/2014/main" id="{22398C95-ABD0-3622-00E2-F31D6C03E8AA}"/>
+              </a:ext>
+            </a:extLst>
+          </p:cNvPr>
+          <p:cNvPicPr>
+            <a:picLocks noChangeAspect="1"/>
+          </p:cNvPicPr>
+          <p:nvPr/>
+        </p:nvPicPr>
+        <p:blipFill>
+          <a:blip r:embed="rId10"/>
+          <a:stretch>
+            <a:fillRect/>
+          </a:stretch>
+        </p:blipFill>
+        <p:spPr>
+          <a:xfrm>
+            <a:off x="8811216" y="4149064"/>
+            <a:ext cx="310896" cy="173736"/>
+          </a:xfrm>
+          <a:prstGeom prst="rect">
+            <a:avLst/>
+          </a:prstGeom>
+        </p:spPr>
+      </p:pic>
+      <p:sp>
+        <p:nvSpPr>
+          <p:cNvPr id="9" name="Text 73">
+            <a:extLst>
+              <a:ext uri="{FF2B5EF4-FFF2-40B4-BE49-F238E27FC236}">
+                <a16:creationId xmlns:a16="http://schemas.microsoft.com/office/drawing/2014/main" id="{FCE72C75-D71F-A75E-E2BF-F0043DDE1093}"/>
+              </a:ext>
+            </a:extLst>
+          </p:cNvPr>
+          <p:cNvSpPr/>
+          <p:nvPr/>
+        </p:nvSpPr>
+        <p:spPr>
+          <a:xfrm>
+            <a:off x="9231840" y="4021048"/>
+            <a:ext cx="2066544" cy="201168"/>
+          </a:xfrm>
+          <a:prstGeom prst="rect">
+            <a:avLst/>
+          </a:prstGeom>
+          <a:noFill/>
+          <a:ln/>
+        </p:spPr>
+        <p:txBody>
+          <a:bodyPr wrap="square" lIns="0" tIns="0" rIns="0" bIns="0" rtlCol="0" anchor="ctr"/>
+          <a:lstStyle/>
+          <a:p>
+            <a:pPr marL="0" indent="0">
+              <a:buNone/>
+            </a:pPr>
+            <a:r>
+              <a:rPr lang="en-US" sz="900" b="1" dirty="0">
+                <a:solidFill>
+                  <a:srgbClr val="1A1D2E"/>
+                </a:solidFill>
+                <a:latin typeface="Calibri" pitchFamily="34" charset="0"/>
+                <a:ea typeface="Calibri" pitchFamily="34" charset="-122"/>
+                <a:cs typeface="Calibri" pitchFamily="34" charset="-120"/>
+              </a:rPr>
+              <a:t>PySpark notebook</a:t>
+            </a:r>
+            <a:endParaRPr lang="en-US" sz="900" dirty="0"/>
+          </a:p>
+        </p:txBody>
+      </p:sp>
+      <p:sp>
+        <p:nvSpPr>
+          <p:cNvPr id="13" name="Text 74">
+            <a:extLst>
+              <a:ext uri="{FF2B5EF4-FFF2-40B4-BE49-F238E27FC236}">
+                <a16:creationId xmlns:a16="http://schemas.microsoft.com/office/drawing/2014/main" id="{AB9515A5-C599-9178-A21A-21992088E7E4}"/>
+              </a:ext>
+            </a:extLst>
+          </p:cNvPr>
+          <p:cNvSpPr/>
+          <p:nvPr/>
+        </p:nvSpPr>
+        <p:spPr>
+          <a:xfrm>
+            <a:off x="9231840" y="4213072"/>
+            <a:ext cx="2066544" cy="219456"/>
+          </a:xfrm>
+          <a:prstGeom prst="rect">
+            <a:avLst/>
+          </a:prstGeom>
+          <a:noFill/>
+          <a:ln/>
+        </p:spPr>
+        <p:txBody>
+          <a:bodyPr wrap="square" lIns="0" tIns="0" rIns="0" bIns="0" rtlCol="0" anchor="ctr"/>
+          <a:lstStyle/>
+          <a:p>
+            <a:pPr marL="0" indent="0">
+              <a:buNone/>
+            </a:pPr>
+            <a:r>
+              <a:rPr lang="en-US" sz="720" dirty="0">
+                <a:solidFill>
+                  <a:srgbClr val="6B7188"/>
+                </a:solidFill>
+                <a:latin typeface="Calibri" pitchFamily="34" charset="0"/>
+                <a:ea typeface="Calibri" pitchFamily="34" charset="-122"/>
+                <a:cs typeface="Calibri" pitchFamily="34" charset="-120"/>
+              </a:rPr>
+              <a:t>Updates to reusable notebook</a:t>
+            </a:r>
+            <a:endParaRPr lang="en-US" sz="720" dirty="0"/>
+          </a:p>
+        </p:txBody>
+      </p:sp>
     </p:spTree>
     <p:extLst>
       <p:ext uri="{BB962C8B-B14F-4D97-AF65-F5344CB8AC3E}">
@@ -9205,7 +9212,7 @@
           </a:lstStyle>
           <a:p>
             <a:r>
-              <a:rPr sz="1100" b="1" dirty="0">
+              <a:rPr sz="1100" b="1">
                 <a:solidFill>
                   <a:srgbClr val="1C2127"/>
                 </a:solidFill>
@@ -9214,7 +9221,7 @@
               <a:t>Approved </a:t>
             </a:r>
             <a:r>
-              <a:rPr lang="en-US" sz="1100" b="1" dirty="0">
+              <a:rPr lang="en-US" sz="1100" b="1">
                 <a:solidFill>
                   <a:srgbClr val="1C2127"/>
                 </a:solidFill>
@@ -15892,7 +15899,7 @@
               <a:buNone/>
             </a:pPr>
             <a:r>
-              <a:rPr lang="en-US" sz="2000" b="1" dirty="0">
+              <a:rPr lang="en-US" sz="2000" b="1">
                 <a:solidFill>
                   <a:srgbClr val="FFFFFF"/>
                 </a:solidFill>
@@ -15902,7 +15909,7 @@
               </a:rPr>
               <a:t>NEXT STEPS</a:t>
             </a:r>
-            <a:endParaRPr lang="en-US" sz="2000" dirty="0"/>
+            <a:endParaRPr lang="en-US" sz="2000"/>
           </a:p>
         </p:txBody>
       </p:sp>
@@ -15937,7 +15944,7 @@
               <a:buNone/>
             </a:pPr>
             <a:r>
-              <a:rPr lang="en-US" sz="800" dirty="0">
+              <a:rPr lang="en-US" sz="800">
                 <a:solidFill>
                   <a:srgbClr val="9AA5AE"/>
                 </a:solidFill>
@@ -15947,7 +15954,7 @@
               </a:rPr>
               <a:t>2</a:t>
             </a:r>
-            <a:endParaRPr lang="en-US" sz="800" dirty="0"/>
+            <a:endParaRPr lang="en-US" sz="800"/>
           </a:p>
         </p:txBody>
       </p:sp>
@@ -16010,7 +16017,15 @@
             </a:pPr>
             <a:r>
               <a:rPr lang="en-US" sz="1600" dirty="0"/>
-              <a:t>Prioritizing CodeGen agent to train on various frameworks and project specific templates.</a:t>
+              <a:t>Prioritizing </a:t>
+            </a:r>
+            <a:r>
+              <a:rPr lang="en-US" sz="1600" dirty="0" err="1"/>
+              <a:t>CodeGen</a:t>
+            </a:r>
+            <a:r>
+              <a:rPr lang="en-US" sz="1600" dirty="0"/>
+              <a:t> agent to train on various frameworks and project specific templates.</a:t>
             </a:r>
           </a:p>
           <a:p>
@@ -16057,7 +16072,15 @@
             </a:pPr>
             <a:r>
               <a:rPr lang="en-US" sz="1600" dirty="0"/>
-              <a:t>Deciding on SQL Server DB vs Databricks Lake base database for Audit or pipeline orchestration</a:t>
+              <a:t>Deciding on SQL Server DB vs Databricks </a:t>
+            </a:r>
+            <a:r>
+              <a:rPr lang="en-US" sz="1600" dirty="0" err="1"/>
+              <a:t>Lakebase</a:t>
+            </a:r>
+            <a:r>
+              <a:rPr lang="en-US" sz="1600" dirty="0"/>
+              <a:t> database for Audit or pipeline orchestration</a:t>
             </a:r>
           </a:p>
           <a:p>
@@ -16109,10 +16132,10 @@
           <a:p>
             <a:pPr algn="ctr"/>
             <a:r>
-              <a:rPr lang="en-US" dirty="0"/>
+              <a:rPr lang="en-US"/>
               <a:t>Action Items</a:t>
             </a:r>
-            <a:endParaRPr lang="en-IN" dirty="0"/>
+            <a:endParaRPr lang="en-IN"/>
           </a:p>
         </p:txBody>
       </p:sp>
@@ -16209,7 +16232,7 @@
               <a:buNone/>
             </a:pPr>
             <a:r>
-              <a:rPr lang="en-US" sz="4000" dirty="0">
+              <a:rPr lang="en-US" sz="4000">
                 <a:solidFill>
                   <a:srgbClr val="0067B1"/>
                 </a:solidFill>
@@ -16219,7 +16242,7 @@
               </a:rPr>
               <a:t>Thank you</a:t>
             </a:r>
-            <a:endParaRPr lang="en-US" sz="4000" dirty="0"/>
+            <a:endParaRPr lang="en-US" sz="4000"/>
           </a:p>
         </p:txBody>
       </p:sp>
@@ -16248,7 +16271,7 @@
               <a:buNone/>
             </a:pPr>
             <a:r>
-              <a:rPr lang="en-US" sz="1700" dirty="0">
+              <a:rPr lang="en-US" sz="1700">
                 <a:solidFill>
                   <a:srgbClr val="3F4A55"/>
                 </a:solidFill>
@@ -16258,7 +16281,7 @@
               </a:rPr>
               <a:t>Two agents. One governed platform. Every hand-off approved by a person.</a:t>
             </a:r>
-            <a:endParaRPr lang="en-US" sz="1700" dirty="0"/>
+            <a:endParaRPr lang="en-US" sz="1700"/>
           </a:p>
         </p:txBody>
       </p:sp>
@@ -16271,454 +16294,6 @@
 </file>
 
 <file path=ppt/slides/slide15.xml><?xml version="1.0" encoding="utf-8"?>
-<p:sld xmlns:a="http://schemas.openxmlformats.org/drawingml/2006/main" xmlns:r="http://schemas.openxmlformats.org/officeDocument/2006/relationships" xmlns:p="http://schemas.openxmlformats.org/presentationml/2006/main">
-  <p:cSld>
-    <p:spTree>
-      <p:nvGrpSpPr>
-        <p:cNvPr id="1" name="">
-          <a:extLst>
-            <a:ext uri="{FF2B5EF4-FFF2-40B4-BE49-F238E27FC236}">
-              <a16:creationId xmlns:a16="http://schemas.microsoft.com/office/drawing/2014/main" id="{4CDBC00A-146C-69FB-D22F-814F8E58CA9F}"/>
-            </a:ext>
-          </a:extLst>
-        </p:cNvPr>
-        <p:cNvGrpSpPr/>
-        <p:nvPr/>
-      </p:nvGrpSpPr>
-      <p:grpSpPr>
-        <a:xfrm>
-          <a:off x="0" y="0"/>
-          <a:ext cx="0" cy="0"/>
-          <a:chOff x="0" y="0"/>
-          <a:chExt cx="0" cy="0"/>
-        </a:xfrm>
-      </p:grpSpPr>
-      <p:sp>
-        <p:nvSpPr>
-          <p:cNvPr id="6" name="TextBox 5">
-            <a:extLst>
-              <a:ext uri="{FF2B5EF4-FFF2-40B4-BE49-F238E27FC236}">
-                <a16:creationId xmlns:a16="http://schemas.microsoft.com/office/drawing/2014/main" id="{03FC44BF-051B-44E7-DC96-B944617975B8}"/>
-              </a:ext>
-            </a:extLst>
-          </p:cNvPr>
-          <p:cNvSpPr txBox="1"/>
-          <p:nvPr/>
-        </p:nvSpPr>
-        <p:spPr>
-          <a:xfrm>
-            <a:off x="5059017" y="3827532"/>
-            <a:ext cx="1938131" cy="615553"/>
-          </a:xfrm>
-          <a:prstGeom prst="rect">
-            <a:avLst/>
-          </a:prstGeom>
-          <a:noFill/>
-        </p:spPr>
-        <p:txBody>
-          <a:bodyPr wrap="square" lIns="0" tIns="0" rIns="0" bIns="0">
-            <a:spAutoFit/>
-          </a:bodyPr>
-          <a:lstStyle/>
-          <a:p>
-            <a:r>
-              <a:rPr lang="en-US" sz="2000">
-                <a:solidFill>
-                  <a:schemeClr val="bg1"/>
-                </a:solidFill>
-              </a:rPr>
-              <a:t>STTM Agent Demo       		</a:t>
-            </a:r>
-          </a:p>
-        </p:txBody>
-      </p:sp>
-      <p:pic>
-        <p:nvPicPr>
-          <p:cNvPr id="4" name="Picture 3">
-            <a:extLst>
-              <a:ext uri="{FF2B5EF4-FFF2-40B4-BE49-F238E27FC236}">
-                <a16:creationId xmlns:a16="http://schemas.microsoft.com/office/drawing/2014/main" id="{7B30B2DE-B516-B578-98DD-9C40D72278F0}"/>
-              </a:ext>
-            </a:extLst>
-          </p:cNvPr>
-          <p:cNvPicPr>
-            <a:picLocks noChangeAspect="1"/>
-          </p:cNvPicPr>
-          <p:nvPr/>
-        </p:nvPicPr>
-        <p:blipFill>
-          <a:blip r:embed="rId2"/>
-          <a:stretch>
-            <a:fillRect/>
-          </a:stretch>
-        </p:blipFill>
-        <p:spPr>
-          <a:xfrm>
-            <a:off x="1994915" y="1385602"/>
-            <a:ext cx="8202170" cy="4086795"/>
-          </a:xfrm>
-          <a:prstGeom prst="rect">
-            <a:avLst/>
-          </a:prstGeom>
-        </p:spPr>
-      </p:pic>
-    </p:spTree>
-    <p:extLst>
-      <p:ext uri="{BB962C8B-B14F-4D97-AF65-F5344CB8AC3E}">
-        <p14:creationId xmlns:p14="http://schemas.microsoft.com/office/powerpoint/2010/main" val="3779776762"/>
-      </p:ext>
-    </p:extLst>
-  </p:cSld>
-  <p:clrMapOvr>
-    <a:masterClrMapping/>
-  </p:clrMapOvr>
-</p:sld>
-</file>
-
-<file path=ppt/slides/slide16.xml><?xml version="1.0" encoding="utf-8"?>
-<p:sld xmlns:a="http://schemas.openxmlformats.org/drawingml/2006/main" xmlns:r="http://schemas.openxmlformats.org/officeDocument/2006/relationships" xmlns:p="http://schemas.openxmlformats.org/presentationml/2006/main">
-  <p:cSld>
-    <p:spTree>
-      <p:nvGrpSpPr>
-        <p:cNvPr id="1" name=""/>
-        <p:cNvGrpSpPr/>
-        <p:nvPr/>
-      </p:nvGrpSpPr>
-      <p:grpSpPr>
-        <a:xfrm>
-          <a:off x="0" y="0"/>
-          <a:ext cx="0" cy="0"/>
-          <a:chOff x="0" y="0"/>
-          <a:chExt cx="0" cy="0"/>
-        </a:xfrm>
-      </p:grpSpPr>
-      <p:pic>
-        <p:nvPicPr>
-          <p:cNvPr id="3" name="Picture 2">
-            <a:extLst>
-              <a:ext uri="{FF2B5EF4-FFF2-40B4-BE49-F238E27FC236}">
-                <a16:creationId xmlns:a16="http://schemas.microsoft.com/office/drawing/2014/main" id="{1F0C9D9E-7EF9-D497-4FB9-E3D1F0FE7259}"/>
-              </a:ext>
-            </a:extLst>
-          </p:cNvPr>
-          <p:cNvPicPr>
-            <a:picLocks noChangeAspect="1"/>
-          </p:cNvPicPr>
-          <p:nvPr/>
-        </p:nvPicPr>
-        <p:blipFill>
-          <a:blip r:embed="rId2"/>
-          <a:stretch>
-            <a:fillRect/>
-          </a:stretch>
-        </p:blipFill>
-        <p:spPr>
-          <a:xfrm>
-            <a:off x="2099705" y="1414181"/>
-            <a:ext cx="7992590" cy="4029637"/>
-          </a:xfrm>
-          <a:prstGeom prst="rect">
-            <a:avLst/>
-          </a:prstGeom>
-        </p:spPr>
-      </p:pic>
-    </p:spTree>
-    <p:extLst>
-      <p:ext uri="{BB962C8B-B14F-4D97-AF65-F5344CB8AC3E}">
-        <p14:creationId xmlns:p14="http://schemas.microsoft.com/office/powerpoint/2010/main" val="2855866632"/>
-      </p:ext>
-    </p:extLst>
-  </p:cSld>
-  <p:clrMapOvr>
-    <a:masterClrMapping/>
-  </p:clrMapOvr>
-</p:sld>
-</file>
-
-<file path=ppt/slides/slide17.xml><?xml version="1.0" encoding="utf-8"?>
-<p:sld xmlns:a="http://schemas.openxmlformats.org/drawingml/2006/main" xmlns:r="http://schemas.openxmlformats.org/officeDocument/2006/relationships" xmlns:p="http://schemas.openxmlformats.org/presentationml/2006/main">
-  <p:cSld>
-    <p:bg>
-      <p:bgPr>
-        <a:blipFill dpi="0" rotWithShape="1">
-          <a:blip r:embed="rId3">
-            <a:lum/>
-          </a:blip>
-          <a:srcRect/>
-          <a:stretch>
-            <a:fillRect/>
-          </a:stretch>
-        </a:blipFill>
-        <a:effectLst/>
-      </p:bgPr>
-    </p:bg>
-    <p:spTree>
-      <p:nvGrpSpPr>
-        <p:cNvPr id="1" name="">
-          <a:extLst>
-            <a:ext uri="{FF2B5EF4-FFF2-40B4-BE49-F238E27FC236}">
-              <a16:creationId xmlns:a16="http://schemas.microsoft.com/office/drawing/2014/main" id="{05A60CE4-8CE0-9D6A-80B3-57527D68E7FE}"/>
-            </a:ext>
-          </a:extLst>
-        </p:cNvPr>
-        <p:cNvGrpSpPr/>
-        <p:nvPr/>
-      </p:nvGrpSpPr>
-      <p:grpSpPr>
-        <a:xfrm>
-          <a:off x="0" y="0"/>
-          <a:ext cx="0" cy="0"/>
-          <a:chOff x="0" y="0"/>
-          <a:chExt cx="0" cy="0"/>
-        </a:xfrm>
-      </p:grpSpPr>
-      <p:sp>
-        <p:nvSpPr>
-          <p:cNvPr id="2" name="Text 0">
-            <a:extLst>
-              <a:ext uri="{FF2B5EF4-FFF2-40B4-BE49-F238E27FC236}">
-                <a16:creationId xmlns:a16="http://schemas.microsoft.com/office/drawing/2014/main" id="{17AA2BCC-54E7-B3A2-4F92-56881F957405}"/>
-              </a:ext>
-            </a:extLst>
-          </p:cNvPr>
-          <p:cNvSpPr/>
-          <p:nvPr/>
-        </p:nvSpPr>
-        <p:spPr>
-          <a:xfrm>
-            <a:off x="329184" y="182880"/>
-            <a:ext cx="7632561" cy="502920"/>
-          </a:xfrm>
-          <a:prstGeom prst="rect">
-            <a:avLst/>
-          </a:prstGeom>
-          <a:noFill/>
-          <a:ln/>
-        </p:spPr>
-        <p:txBody>
-          <a:bodyPr wrap="square" lIns="0" tIns="0" rIns="0" bIns="0" rtlCol="0" anchor="ctr"/>
-          <a:lstStyle/>
-          <a:p>
-            <a:pPr marL="0" indent="0">
-              <a:buNone/>
-            </a:pPr>
-            <a:r>
-              <a:rPr lang="en-US" sz="2000" b="1">
-                <a:solidFill>
-                  <a:srgbClr val="FFFFFF"/>
-                </a:solidFill>
-                <a:latin typeface="Calibri" pitchFamily="34" charset="0"/>
-                <a:ea typeface="Calibri" pitchFamily="34" charset="-122"/>
-                <a:cs typeface="Calibri" pitchFamily="34" charset="-120"/>
-              </a:rPr>
-              <a:t>ARCHITECTURE </a:t>
-            </a:r>
-            <a:endParaRPr lang="en-US" sz="2000"/>
-          </a:p>
-        </p:txBody>
-      </p:sp>
-      <p:sp>
-        <p:nvSpPr>
-          <p:cNvPr id="3" name="Text 1">
-            <a:extLst>
-              <a:ext uri="{FF2B5EF4-FFF2-40B4-BE49-F238E27FC236}">
-                <a16:creationId xmlns:a16="http://schemas.microsoft.com/office/drawing/2014/main" id="{CAE2219D-F898-C616-BE2F-9A725DB553C2}"/>
-              </a:ext>
-            </a:extLst>
-          </p:cNvPr>
-          <p:cNvSpPr/>
-          <p:nvPr/>
-        </p:nvSpPr>
-        <p:spPr>
-          <a:xfrm>
-            <a:off x="320040" y="1170432"/>
-            <a:ext cx="11521440" cy="310896"/>
-          </a:xfrm>
-          <a:prstGeom prst="rect">
-            <a:avLst/>
-          </a:prstGeom>
-          <a:noFill/>
-          <a:ln/>
-        </p:spPr>
-        <p:txBody>
-          <a:bodyPr wrap="square" lIns="0" tIns="0" rIns="0" bIns="0" rtlCol="0" anchor="ctr"/>
-          <a:lstStyle/>
-          <a:p>
-            <a:pPr marL="0" indent="0">
-              <a:buNone/>
-            </a:pPr>
-            <a:r>
-              <a:rPr lang="en-US" sz="1500" b="1">
-                <a:solidFill>
-                  <a:srgbClr val="0067B1"/>
-                </a:solidFill>
-                <a:latin typeface="Calibri" pitchFamily="34" charset="0"/>
-                <a:ea typeface="Calibri" pitchFamily="34" charset="-122"/>
-                <a:cs typeface="Calibri" pitchFamily="34" charset="-120"/>
-              </a:rPr>
-              <a:t> </a:t>
-            </a:r>
-            <a:endParaRPr lang="en-US" sz="1500"/>
-          </a:p>
-        </p:txBody>
-      </p:sp>
-      <p:sp>
-        <p:nvSpPr>
-          <p:cNvPr id="5" name="Text 3">
-            <a:extLst>
-              <a:ext uri="{FF2B5EF4-FFF2-40B4-BE49-F238E27FC236}">
-                <a16:creationId xmlns:a16="http://schemas.microsoft.com/office/drawing/2014/main" id="{A6E180C5-8BFC-9422-3439-EE164EB86B11}"/>
-              </a:ext>
-            </a:extLst>
-          </p:cNvPr>
-          <p:cNvSpPr/>
-          <p:nvPr/>
-        </p:nvSpPr>
-        <p:spPr>
-          <a:xfrm>
-            <a:off x="2286000" y="2029968"/>
-            <a:ext cx="8778240" cy="310896"/>
-          </a:xfrm>
-          <a:prstGeom prst="rect">
-            <a:avLst/>
-          </a:prstGeom>
-          <a:noFill/>
-          <a:ln/>
-        </p:spPr>
-        <p:txBody>
-          <a:bodyPr wrap="square" lIns="0" tIns="0" rIns="0" bIns="0" rtlCol="0" anchor="ctr"/>
-          <a:lstStyle/>
-          <a:p>
-            <a:pPr marL="0" indent="0">
-              <a:buNone/>
-            </a:pPr>
-            <a:endParaRPr lang="en-US" sz="1400"/>
-          </a:p>
-        </p:txBody>
-      </p:sp>
-      <p:sp>
-        <p:nvSpPr>
-          <p:cNvPr id="6" name="Text 4">
-            <a:extLst>
-              <a:ext uri="{FF2B5EF4-FFF2-40B4-BE49-F238E27FC236}">
-                <a16:creationId xmlns:a16="http://schemas.microsoft.com/office/drawing/2014/main" id="{A226434F-1903-C7AD-989C-7AFC75C8DD35}"/>
-              </a:ext>
-            </a:extLst>
-          </p:cNvPr>
-          <p:cNvSpPr/>
-          <p:nvPr/>
-        </p:nvSpPr>
-        <p:spPr>
-          <a:xfrm>
-            <a:off x="2286000" y="2542032"/>
-            <a:ext cx="8778240" cy="384048"/>
-          </a:xfrm>
-          <a:prstGeom prst="rect">
-            <a:avLst/>
-          </a:prstGeom>
-          <a:noFill/>
-          <a:ln/>
-        </p:spPr>
-        <p:txBody>
-          <a:bodyPr wrap="square" lIns="0" tIns="0" rIns="0" bIns="0" rtlCol="0" anchor="t"/>
-          <a:lstStyle/>
-          <a:p>
-            <a:pPr marL="0" indent="0">
-              <a:buNone/>
-            </a:pPr>
-            <a:endParaRPr lang="en-US" sz="1050"/>
-          </a:p>
-        </p:txBody>
-      </p:sp>
-      <p:sp>
-        <p:nvSpPr>
-          <p:cNvPr id="14" name="Text 12">
-            <a:extLst>
-              <a:ext uri="{FF2B5EF4-FFF2-40B4-BE49-F238E27FC236}">
-                <a16:creationId xmlns:a16="http://schemas.microsoft.com/office/drawing/2014/main" id="{30D5FED5-FB9B-DAD7-5213-E81C5F8F2F5B}"/>
-              </a:ext>
-            </a:extLst>
-          </p:cNvPr>
-          <p:cNvSpPr/>
-          <p:nvPr/>
-        </p:nvSpPr>
-        <p:spPr>
-          <a:xfrm>
-            <a:off x="11292840" y="5971032"/>
-            <a:ext cx="548640" cy="182880"/>
-          </a:xfrm>
-          <a:prstGeom prst="rect">
-            <a:avLst/>
-          </a:prstGeom>
-          <a:noFill/>
-          <a:ln/>
-        </p:spPr>
-        <p:txBody>
-          <a:bodyPr wrap="square" lIns="0" tIns="0" rIns="0" bIns="0" rtlCol="0" anchor="ctr"/>
-          <a:lstStyle/>
-          <a:p>
-            <a:pPr marL="0" indent="0" algn="r">
-              <a:buNone/>
-            </a:pPr>
-            <a:r>
-              <a:rPr lang="en-US" sz="800">
-                <a:solidFill>
-                  <a:srgbClr val="9AA5AE"/>
-                </a:solidFill>
-                <a:latin typeface="Calibri" pitchFamily="34" charset="0"/>
-                <a:ea typeface="Calibri" pitchFamily="34" charset="-122"/>
-                <a:cs typeface="Calibri" pitchFamily="34" charset="-120"/>
-              </a:rPr>
-              <a:t>2</a:t>
-            </a:r>
-            <a:endParaRPr lang="en-US" sz="800"/>
-          </a:p>
-        </p:txBody>
-      </p:sp>
-      <p:pic>
-        <p:nvPicPr>
-          <p:cNvPr id="15" name="Picture 14">
-            <a:extLst>
-              <a:ext uri="{FF2B5EF4-FFF2-40B4-BE49-F238E27FC236}">
-                <a16:creationId xmlns:a16="http://schemas.microsoft.com/office/drawing/2014/main" id="{402B83AB-91D8-8B18-49B4-F9129D92B2F2}"/>
-              </a:ext>
-            </a:extLst>
-          </p:cNvPr>
-          <p:cNvPicPr>
-            <a:picLocks noChangeAspect="1"/>
-          </p:cNvPicPr>
-          <p:nvPr/>
-        </p:nvPicPr>
-        <p:blipFill>
-          <a:blip r:embed="rId4"/>
-          <a:stretch>
-            <a:fillRect/>
-          </a:stretch>
-        </p:blipFill>
-        <p:spPr>
-          <a:xfrm>
-            <a:off x="642551" y="1000897"/>
-            <a:ext cx="10898660" cy="5153015"/>
-          </a:xfrm>
-          <a:prstGeom prst="rect">
-            <a:avLst/>
-          </a:prstGeom>
-        </p:spPr>
-      </p:pic>
-    </p:spTree>
-    <p:extLst>
-      <p:ext uri="{BB962C8B-B14F-4D97-AF65-F5344CB8AC3E}">
-        <p14:creationId xmlns:p14="http://schemas.microsoft.com/office/powerpoint/2010/main" val="3003698055"/>
-      </p:ext>
-    </p:extLst>
-  </p:cSld>
-  <p:clrMapOvr>
-    <a:masterClrMapping/>
-  </p:clrMapOvr>
-</p:sld>
-</file>
-
-<file path=ppt/slides/slide18.xml><?xml version="1.0" encoding="utf-8"?>
 <p:sld xmlns:a="http://schemas.openxmlformats.org/drawingml/2006/main" xmlns:r="http://schemas.openxmlformats.org/officeDocument/2006/relationships" xmlns:p="http://schemas.openxmlformats.org/presentationml/2006/main">
   <p:cSld>
     <p:spTree>
@@ -17129,7 +16704,7 @@
           <a:p>
             <a:pPr algn="l"/>
             <a:r>
-              <a:rPr sz="2800" b="1" dirty="0">
+              <a:rPr sz="2800" b="1">
                 <a:solidFill>
                   <a:srgbClr val="111418"/>
                 </a:solidFill>
@@ -17138,7 +16713,7 @@
               <a:t>FRD → STTM Agent</a:t>
             </a:r>
             <a:r>
-              <a:rPr sz="1500" b="0" dirty="0">
+              <a:rPr sz="1500" b="0">
                 <a:solidFill>
                   <a:srgbClr val="5F6B7C"/>
                 </a:solidFill>
@@ -20312,7 +19887,7 @@
 </p:sld>
 </file>
 
-<file path=ppt/slides/slide19.xml><?xml version="1.0" encoding="utf-8"?>
+<file path=ppt/slides/slide16.xml><?xml version="1.0" encoding="utf-8"?>
 <p:sld xmlns:a="http://schemas.openxmlformats.org/drawingml/2006/main" xmlns:r="http://schemas.openxmlformats.org/officeDocument/2006/relationships" xmlns:p="http://schemas.openxmlformats.org/presentationml/2006/main">
   <p:cSld name="Slide 7">
     <p:bg>
@@ -37857,7 +37432,7 @@
               <a:buNone/>
             </a:pPr>
             <a:r>
-              <a:rPr lang="en-US" sz="2000" b="1" dirty="0">
+              <a:rPr lang="en-US" sz="2000" b="1">
                 <a:solidFill>
                   <a:srgbClr val="FFFFFF"/>
                 </a:solidFill>
@@ -37867,7 +37442,7 @@
               </a:rPr>
               <a:t>PROGRAM OVERVIEW</a:t>
             </a:r>
-            <a:endParaRPr lang="en-US" sz="2000" dirty="0"/>
+            <a:endParaRPr lang="en-US" sz="2000"/>
           </a:p>
         </p:txBody>
       </p:sp>
@@ -37944,7 +37519,7 @@
               </a:rPr>
               <a:t>01</a:t>
             </a:r>
-            <a:endParaRPr lang="en-US" sz="3800" dirty="0"/>
+            <a:endParaRPr lang="en-US" sz="3800"/>
           </a:p>
         </p:txBody>
       </p:sp>
@@ -37973,7 +37548,7 @@
               <a:buNone/>
             </a:pPr>
             <a:r>
-              <a:rPr lang="en-US" b="1" dirty="0">
+              <a:rPr lang="en-US" b="1">
                 <a:solidFill>
                   <a:srgbClr val="0067B1"/>
                 </a:solidFill>
@@ -37982,7 +37557,7 @@
               </a:rPr>
               <a:t>How the two agents fit together</a:t>
             </a:r>
-            <a:endParaRPr lang="en-US" dirty="0"/>
+            <a:endParaRPr lang="en-US"/>
           </a:p>
         </p:txBody>
       </p:sp>
@@ -38011,7 +37586,7 @@
               <a:buNone/>
             </a:pPr>
             <a:r>
-              <a:rPr lang="en-US" sz="1200" dirty="0">
+              <a:rPr lang="en-US" sz="1200">
                 <a:solidFill>
                   <a:srgbClr val="5A6875"/>
                 </a:solidFill>
@@ -38021,7 +37596,7 @@
               <a:t>One relay from an approved FRD through to generated </a:t>
             </a:r>
             <a:r>
-              <a:rPr lang="en-US" sz="1400" dirty="0">
+              <a:rPr lang="en-US" sz="1400">
                 <a:solidFill>
                   <a:srgbClr val="5A6875"/>
                 </a:solidFill>
@@ -38031,7 +37606,7 @@
               <a:t>pipeline</a:t>
             </a:r>
             <a:r>
-              <a:rPr lang="en-US" sz="1200" dirty="0">
+              <a:rPr lang="en-US" sz="1200">
                 <a:solidFill>
                   <a:srgbClr val="5A6875"/>
                 </a:solidFill>
@@ -38040,7 +37615,7 @@
               </a:rPr>
               <a:t> code — with a human gate at each hand-off</a:t>
             </a:r>
-            <a:endParaRPr lang="en-US" sz="1200" dirty="0"/>
+            <a:endParaRPr lang="en-US" sz="1200"/>
           </a:p>
         </p:txBody>
       </p:sp>
@@ -38078,7 +37653,7 @@
               </a:rPr>
               <a:t>02</a:t>
             </a:r>
-            <a:endParaRPr lang="en-US" sz="3800" dirty="0"/>
+            <a:endParaRPr lang="en-US" sz="3800"/>
           </a:p>
         </p:txBody>
       </p:sp>
@@ -38107,7 +37682,7 @@
               <a:buNone/>
             </a:pPr>
             <a:r>
-              <a:rPr lang="en-US" b="1" dirty="0">
+              <a:rPr lang="en-US" b="1">
                 <a:solidFill>
                   <a:srgbClr val="0067B1"/>
                 </a:solidFill>
@@ -38116,7 +37691,7 @@
               </a:rPr>
               <a:t>STTM Agent Overview and Demo</a:t>
             </a:r>
-            <a:endParaRPr lang="en-US" dirty="0"/>
+            <a:endParaRPr lang="en-US"/>
           </a:p>
         </p:txBody>
       </p:sp>
@@ -38145,7 +37720,7 @@
               <a:buNone/>
             </a:pPr>
             <a:r>
-              <a:rPr lang="en-US" sz="1200" dirty="0">
+              <a:rPr lang="en-US" sz="1200">
                 <a:solidFill>
                   <a:srgbClr val="5A6875"/>
                 </a:solidFill>
@@ -38154,7 +37729,7 @@
               </a:rPr>
               <a:t>The source-to-target mapping workbook, filled in from the approved FRD and returned to SharePoint</a:t>
             </a:r>
-            <a:endParaRPr lang="en-US" sz="1200" dirty="0"/>
+            <a:endParaRPr lang="en-US" sz="1200"/>
           </a:p>
         </p:txBody>
       </p:sp>
@@ -38183,7 +37758,7 @@
               <a:buNone/>
             </a:pPr>
             <a:r>
-              <a:rPr lang="en-US" sz="3800" dirty="0">
+              <a:rPr lang="en-US" sz="3800">
                 <a:solidFill>
                   <a:srgbClr val="0067B1"/>
                 </a:solidFill>
@@ -38192,7 +37767,7 @@
               </a:rPr>
               <a:t>03</a:t>
             </a:r>
-            <a:endParaRPr lang="en-US" sz="3800" dirty="0"/>
+            <a:endParaRPr lang="en-US" sz="3800"/>
           </a:p>
         </p:txBody>
       </p:sp>
@@ -38221,7 +37796,7 @@
               <a:buNone/>
             </a:pPr>
             <a:r>
-              <a:rPr lang="en-US" sz="800" dirty="0">
+              <a:rPr lang="en-US" sz="800">
                 <a:solidFill>
                   <a:srgbClr val="9AA5AE"/>
                 </a:solidFill>
@@ -38231,7 +37806,7 @@
               </a:rPr>
               <a:t>2</a:t>
             </a:r>
-            <a:endParaRPr lang="en-US" sz="800" dirty="0"/>
+            <a:endParaRPr lang="en-US" sz="800"/>
           </a:p>
         </p:txBody>
       </p:sp>
@@ -38266,7 +37841,7 @@
               <a:buNone/>
             </a:pPr>
             <a:r>
-              <a:rPr lang="en-US" b="1" dirty="0" err="1">
+              <a:rPr lang="en-US" b="1" err="1">
                 <a:solidFill>
                   <a:srgbClr val="0067B1"/>
                 </a:solidFill>
@@ -38276,7 +37851,7 @@
               <a:t>CodeGen</a:t>
             </a:r>
             <a:r>
-              <a:rPr lang="en-US" b="1" dirty="0">
+              <a:rPr lang="en-US" b="1">
                 <a:solidFill>
                   <a:srgbClr val="0067B1"/>
                 </a:solidFill>
@@ -38285,7 +37860,7 @@
               </a:rPr>
               <a:t> /Data Engineer Agent Overview and Demo</a:t>
             </a:r>
-            <a:endParaRPr lang="en-US" dirty="0"/>
+            <a:endParaRPr lang="en-US"/>
           </a:p>
         </p:txBody>
       </p:sp>
@@ -38320,7 +37895,7 @@
               <a:buNone/>
             </a:pPr>
             <a:r>
-              <a:rPr lang="en-US" sz="3800" dirty="0">
+              <a:rPr lang="en-US" sz="3800">
                 <a:solidFill>
                   <a:srgbClr val="0067B1"/>
                 </a:solidFill>
@@ -38329,7 +37904,7 @@
               </a:rPr>
               <a:t>04</a:t>
             </a:r>
-            <a:endParaRPr lang="en-US" sz="3800" dirty="0"/>
+            <a:endParaRPr lang="en-US" sz="3800"/>
           </a:p>
         </p:txBody>
       </p:sp>
@@ -38364,7 +37939,7 @@
               <a:buNone/>
             </a:pPr>
             <a:r>
-              <a:rPr lang="en-US" b="1" dirty="0">
+              <a:rPr lang="en-US" b="1">
                 <a:solidFill>
                   <a:srgbClr val="0067B1"/>
                 </a:solidFill>
@@ -38373,7 +37948,7 @@
               </a:rPr>
               <a:t>Next Steps and Prioritize Agent Training and Deployment </a:t>
             </a:r>
-            <a:endParaRPr lang="en-US" dirty="0"/>
+            <a:endParaRPr lang="en-US"/>
           </a:p>
         </p:txBody>
       </p:sp>
@@ -38450,14 +38025,14 @@
           <a:lstStyle/>
           <a:p>
             <a:r>
-              <a:rPr lang="en-US" sz="2000" dirty="0">
+              <a:rPr lang="en-US" sz="2000">
                 <a:solidFill>
                   <a:schemeClr val="bg1"/>
                 </a:solidFill>
               </a:rPr>
               <a:t>TEAM INTRODUCTIONS</a:t>
             </a:r>
-            <a:endParaRPr lang="en-US" sz="2000" dirty="0"/>
+            <a:endParaRPr lang="en-US" sz="2000"/>
           </a:p>
         </p:txBody>
       </p:sp>
@@ -40421,14 +39996,14 @@
           </a:lstStyle>
           <a:p>
             <a:r>
-              <a:rPr lang="en-US" sz="2000" b="1" dirty="0">
+              <a:rPr lang="en-US" sz="2000" b="1">
                 <a:solidFill>
                   <a:schemeClr val="bg1"/>
                 </a:solidFill>
               </a:rPr>
               <a:t>Four agents, two waves — all live by Jan 31, 2026</a:t>
             </a:r>
-            <a:endParaRPr lang="en-IN" sz="2000" b="1" dirty="0">
+            <a:endParaRPr lang="en-IN" sz="2000" b="1">
               <a:solidFill>
                 <a:schemeClr val="bg1"/>
               </a:solidFill>
@@ -40605,7 +40180,7 @@
               <a:buNone/>
             </a:pPr>
             <a:r>
-              <a:rPr lang="en-IN" dirty="0">
+              <a:rPr lang="en-IN">
                 <a:solidFill>
                   <a:schemeClr val="bg1"/>
                 </a:solidFill>
@@ -40614,7 +40189,7 @@
             </a:r>
           </a:p>
           <a:p>
-            <a:endParaRPr lang="en-IN" dirty="0"/>
+            <a:endParaRPr lang="en-IN"/>
           </a:p>
         </p:txBody>
       </p:sp>
@@ -40994,7 +40569,7 @@
               <a:buNone/>
             </a:pPr>
             <a:r>
-              <a:rPr lang="en-US" sz="2000" b="1" dirty="0">
+              <a:rPr lang="en-US" sz="2000" b="1">
                 <a:solidFill>
                   <a:srgbClr val="FFFFFF"/>
                 </a:solidFill>
@@ -41004,7 +40579,7 @@
               </a:rPr>
               <a:t>THE PROGRAM AT A GLANCE</a:t>
             </a:r>
-            <a:endParaRPr lang="en-US" sz="2000" dirty="0"/>
+            <a:endParaRPr lang="en-US" sz="2000"/>
           </a:p>
         </p:txBody>
       </p:sp>
@@ -41033,7 +40608,7 @@
               <a:buNone/>
             </a:pPr>
             <a:r>
-              <a:rPr lang="en-US" sz="1500" b="1" dirty="0">
+              <a:rPr lang="en-US" sz="1500" b="1">
                 <a:solidFill>
                   <a:srgbClr val="0067B1"/>
                 </a:solidFill>
@@ -41043,7 +40618,7 @@
               </a:rPr>
               <a:t>Two agents, one relay — from an approved FRD through to generated pipeline code</a:t>
             </a:r>
-            <a:endParaRPr lang="en-US" sz="1500" dirty="0"/>
+            <a:endParaRPr lang="en-US" sz="1500"/>
           </a:p>
         </p:txBody>
       </p:sp>
@@ -41106,7 +40681,7 @@
               <a:buNone/>
             </a:pPr>
             <a:r>
-              <a:rPr lang="en-US" sz="1250" b="1" dirty="0">
+              <a:rPr lang="en-US" sz="1250" b="1">
                 <a:solidFill>
                   <a:srgbClr val="2E3350"/>
                 </a:solidFill>
@@ -41116,7 +40691,7 @@
               </a:rPr>
               <a:t>FRD</a:t>
             </a:r>
-            <a:endParaRPr lang="en-US" sz="1250" dirty="0"/>
+            <a:endParaRPr lang="en-US" sz="1250"/>
           </a:p>
         </p:txBody>
       </p:sp>
@@ -41145,7 +40720,7 @@
               <a:buNone/>
             </a:pPr>
             <a:r>
-              <a:rPr lang="en-US" sz="900" dirty="0">
+              <a:rPr lang="en-US" sz="900">
                 <a:solidFill>
                   <a:srgbClr val="5A6875"/>
                 </a:solidFill>
@@ -41155,14 +40730,14 @@
               </a:rPr>
               <a:t>approved,</a:t>
             </a:r>
-            <a:endParaRPr lang="en-US" sz="900" dirty="0"/>
+            <a:endParaRPr lang="en-US" sz="900"/>
           </a:p>
           <a:p>
             <a:pPr marL="0" indent="0" algn="ctr">
               <a:buNone/>
             </a:pPr>
             <a:r>
-              <a:rPr lang="en-US" sz="900" dirty="0">
+              <a:rPr lang="en-US" sz="900">
                 <a:solidFill>
                   <a:srgbClr val="5A6875"/>
                 </a:solidFill>
@@ -41172,7 +40747,7 @@
               </a:rPr>
               <a:t>in SharePoint</a:t>
             </a:r>
-            <a:endParaRPr lang="en-US" sz="900" dirty="0"/>
+            <a:endParaRPr lang="en-US" sz="900"/>
           </a:p>
         </p:txBody>
       </p:sp>
@@ -41235,7 +40810,7 @@
               <a:buNone/>
             </a:pPr>
             <a:r>
-              <a:rPr lang="en-US" sz="900" b="1" kern="0" spc="100" dirty="0">
+              <a:rPr lang="en-US" sz="900" b="1" kern="0" spc="100">
                 <a:solidFill>
                   <a:srgbClr val="9FD3F0"/>
                 </a:solidFill>
@@ -41245,7 +40820,7 @@
               </a:rPr>
               <a:t>Agent 1</a:t>
             </a:r>
-            <a:endParaRPr lang="en-US" sz="900" dirty="0"/>
+            <a:endParaRPr lang="en-US" sz="900"/>
           </a:p>
         </p:txBody>
       </p:sp>
@@ -41274,7 +40849,7 @@
               <a:buNone/>
             </a:pPr>
             <a:r>
-              <a:rPr lang="en-US" sz="1500" b="1" dirty="0">
+              <a:rPr lang="en-US" sz="1500" b="1">
                 <a:solidFill>
                   <a:srgbClr val="FFFFFF"/>
                 </a:solidFill>
@@ -41284,7 +40859,7 @@
               </a:rPr>
               <a:t>FRD → STTM</a:t>
             </a:r>
-            <a:endParaRPr lang="en-US" sz="1500" dirty="0"/>
+            <a:endParaRPr lang="en-US" sz="1500"/>
           </a:p>
         </p:txBody>
       </p:sp>
@@ -41347,7 +40922,7 @@
               <a:buNone/>
             </a:pPr>
             <a:r>
-              <a:rPr lang="en-US" sz="800" b="1" dirty="0">
+              <a:rPr lang="en-US" sz="800" b="1">
                 <a:solidFill>
                   <a:srgbClr val="FFFFFF"/>
                 </a:solidFill>
@@ -41357,7 +40932,7 @@
               </a:rPr>
               <a:t>human gate</a:t>
             </a:r>
-            <a:endParaRPr lang="en-US" sz="800" dirty="0"/>
+            <a:endParaRPr lang="en-US" sz="800"/>
           </a:p>
         </p:txBody>
       </p:sp>
@@ -41420,7 +40995,7 @@
               <a:buNone/>
             </a:pPr>
             <a:r>
-              <a:rPr lang="en-US" sz="1250" b="1" dirty="0">
+              <a:rPr lang="en-US" sz="1250" b="1">
                 <a:solidFill>
                   <a:srgbClr val="2E3350"/>
                 </a:solidFill>
@@ -41430,7 +41005,7 @@
               </a:rPr>
               <a:t>STTM</a:t>
             </a:r>
-            <a:endParaRPr lang="en-US" sz="1250" dirty="0"/>
+            <a:endParaRPr lang="en-US" sz="1250"/>
           </a:p>
         </p:txBody>
       </p:sp>
@@ -41459,7 +41034,7 @@
               <a:buNone/>
             </a:pPr>
             <a:r>
-              <a:rPr lang="en-US" sz="900" dirty="0">
+              <a:rPr lang="en-US" sz="900">
                 <a:solidFill>
                   <a:srgbClr val="5A6875"/>
                 </a:solidFill>
@@ -41469,14 +41044,14 @@
               </a:rPr>
               <a:t>workbook,</a:t>
             </a:r>
-            <a:endParaRPr lang="en-US" sz="900" dirty="0"/>
+            <a:endParaRPr lang="en-US" sz="900"/>
           </a:p>
           <a:p>
             <a:pPr marL="0" indent="0" algn="ctr">
               <a:buNone/>
             </a:pPr>
             <a:r>
-              <a:rPr lang="en-US" sz="900" dirty="0">
+              <a:rPr lang="en-US" sz="900">
                 <a:solidFill>
                   <a:srgbClr val="5A6875"/>
                 </a:solidFill>
@@ -41486,7 +41061,7 @@
               </a:rPr>
               <a:t>in SharePoint</a:t>
             </a:r>
-            <a:endParaRPr lang="en-US" sz="900" dirty="0"/>
+            <a:endParaRPr lang="en-US" sz="900"/>
           </a:p>
         </p:txBody>
       </p:sp>
@@ -41549,7 +41124,7 @@
               <a:buNone/>
             </a:pPr>
             <a:r>
-              <a:rPr lang="en-US" sz="900" b="1" kern="0" spc="100" dirty="0">
+              <a:rPr lang="en-US" sz="900" b="1" kern="0" spc="100">
                 <a:solidFill>
                   <a:srgbClr val="9FD3F0"/>
                 </a:solidFill>
@@ -41559,7 +41134,7 @@
               </a:rPr>
               <a:t>Agent 2</a:t>
             </a:r>
-            <a:endParaRPr lang="en-US" sz="900" dirty="0"/>
+            <a:endParaRPr lang="en-US" sz="900"/>
           </a:p>
         </p:txBody>
       </p:sp>
@@ -41588,7 +41163,7 @@
               <a:buNone/>
             </a:pPr>
             <a:r>
-              <a:rPr lang="en-US" sz="1500" b="1" dirty="0">
+              <a:rPr lang="en-US" sz="1500" b="1">
                 <a:solidFill>
                   <a:srgbClr val="FFFFFF"/>
                 </a:solidFill>
@@ -41598,7 +41173,7 @@
               </a:rPr>
               <a:t>CodeGen</a:t>
             </a:r>
-            <a:endParaRPr lang="en-US" sz="1500" dirty="0"/>
+            <a:endParaRPr lang="en-US" sz="1500"/>
           </a:p>
         </p:txBody>
       </p:sp>
@@ -41661,7 +41236,7 @@
               <a:buNone/>
             </a:pPr>
             <a:r>
-              <a:rPr lang="en-US" sz="800" b="1" dirty="0">
+              <a:rPr lang="en-US" sz="800" b="1">
                 <a:solidFill>
                   <a:srgbClr val="FFFFFF"/>
                 </a:solidFill>
@@ -41671,7 +41246,7 @@
               </a:rPr>
               <a:t>human gate</a:t>
             </a:r>
-            <a:endParaRPr lang="en-US" sz="800" dirty="0"/>
+            <a:endParaRPr lang="en-US" sz="800"/>
           </a:p>
         </p:txBody>
       </p:sp>
@@ -41734,7 +41309,7 @@
               <a:buNone/>
             </a:pPr>
             <a:r>
-              <a:rPr lang="en-US" sz="1250" b="1" dirty="0">
+              <a:rPr lang="en-US" sz="1250" b="1">
                 <a:solidFill>
                   <a:srgbClr val="2E3350"/>
                 </a:solidFill>
@@ -41744,7 +41319,7 @@
               </a:rPr>
               <a:t>Pipeline code</a:t>
             </a:r>
-            <a:endParaRPr lang="en-US" sz="1250" dirty="0"/>
+            <a:endParaRPr lang="en-US" sz="1250"/>
           </a:p>
         </p:txBody>
       </p:sp>
@@ -41773,7 +41348,7 @@
               <a:buNone/>
             </a:pPr>
             <a:r>
-              <a:rPr lang="en-US" sz="900" dirty="0">
+              <a:rPr lang="en-US" sz="900">
                 <a:solidFill>
                   <a:srgbClr val="5A6875"/>
                 </a:solidFill>
@@ -41783,14 +41358,14 @@
               </a:rPr>
               <a:t>transforms, DDL,</a:t>
             </a:r>
-            <a:endParaRPr lang="en-US" sz="900" dirty="0"/>
+            <a:endParaRPr lang="en-US" sz="900"/>
           </a:p>
           <a:p>
             <a:pPr marL="0" indent="0" algn="ctr">
               <a:buNone/>
             </a:pPr>
             <a:r>
-              <a:rPr lang="en-US" sz="900" dirty="0">
+              <a:rPr lang="en-US" sz="900">
                 <a:solidFill>
                   <a:srgbClr val="5A6875"/>
                 </a:solidFill>
@@ -41800,7 +41375,7 @@
               </a:rPr>
               <a:t>tests, job config</a:t>
             </a:r>
-            <a:endParaRPr lang="en-US" sz="900" dirty="0"/>
+            <a:endParaRPr lang="en-US" sz="900"/>
           </a:p>
         </p:txBody>
       </p:sp>
@@ -41829,7 +41404,7 @@
               <a:buNone/>
             </a:pPr>
             <a:r>
-              <a:rPr lang="en-US" sz="1050" i="1" dirty="0">
+              <a:rPr lang="en-US" sz="1050" i="1">
                 <a:solidFill>
                   <a:srgbClr val="5A6875"/>
                 </a:solidFill>
@@ -41839,7 +41414,7 @@
               </a:rPr>
               <a:t>The FRD is authored and approved by your team. Agent 1's workbook is Agent 2's input — and nothing moves downstream until a named person approves it.</a:t>
             </a:r>
-            <a:endParaRPr lang="en-US" sz="1050" dirty="0"/>
+            <a:endParaRPr lang="en-US" sz="1050"/>
           </a:p>
         </p:txBody>
       </p:sp>
@@ -41868,7 +41443,7 @@
               <a:buNone/>
             </a:pPr>
             <a:r>
-              <a:rPr lang="en-US" sz="1050" i="1" dirty="0">
+              <a:rPr lang="en-US" sz="1050" i="1">
                 <a:solidFill>
                   <a:srgbClr val="5A6875"/>
                 </a:solidFill>
@@ -41878,7 +41453,7 @@
               </a:rPr>
               <a:t>FRDs and STTM workbooks are read from, and written back to, the AmeriHealth SharePoint document library through the Microsoft Graph API.</a:t>
             </a:r>
-            <a:endParaRPr lang="en-US" sz="1050" dirty="0"/>
+            <a:endParaRPr lang="en-US" sz="1050"/>
           </a:p>
         </p:txBody>
       </p:sp>
@@ -41999,7 +41574,7 @@
               <a:buNone/>
             </a:pPr>
             <a:r>
-              <a:rPr lang="en-US" sz="1150" b="1" dirty="0">
+              <a:rPr lang="en-US" sz="1150" b="1">
                 <a:solidFill>
                   <a:srgbClr val="0067B1"/>
                 </a:solidFill>
@@ -42009,7 +41584,7 @@
               </a:rPr>
               <a:t>The AI only ever drafts</a:t>
             </a:r>
-            <a:endParaRPr lang="en-US" sz="1150" dirty="0"/>
+            <a:endParaRPr lang="en-US" sz="1150"/>
           </a:p>
         </p:txBody>
       </p:sp>
@@ -42038,7 +41613,7 @@
               <a:buNone/>
             </a:pPr>
             <a:r>
-              <a:rPr lang="en-US" sz="900" dirty="0">
+              <a:rPr lang="en-US" sz="900">
                 <a:solidFill>
                   <a:srgbClr val="5A6875"/>
                 </a:solidFill>
@@ -42048,7 +41623,7 @@
               </a:rPr>
               <a:t>Validation, grounding, gating and rendering are all ordinary code. The model is never the arbiter of whether its own output is right.</a:t>
             </a:r>
-            <a:endParaRPr lang="en-US" sz="900" dirty="0"/>
+            <a:endParaRPr lang="en-US" sz="900"/>
           </a:p>
         </p:txBody>
       </p:sp>
@@ -42169,7 +41744,7 @@
               <a:buNone/>
             </a:pPr>
             <a:r>
-              <a:rPr lang="en-US" sz="1150" b="1" dirty="0">
+              <a:rPr lang="en-US" sz="1150" b="1">
                 <a:solidFill>
                   <a:srgbClr val="0067B1"/>
                 </a:solidFill>
@@ -42179,7 +41754,7 @@
               </a:rPr>
               <a:t>Every claim cites its source</a:t>
             </a:r>
-            <a:endParaRPr lang="en-US" sz="1150" dirty="0"/>
+            <a:endParaRPr lang="en-US" sz="1150"/>
           </a:p>
         </p:txBody>
       </p:sp>
@@ -42208,7 +41783,7 @@
               <a:buNone/>
             </a:pPr>
             <a:r>
-              <a:rPr lang="en-US" sz="900" dirty="0">
+              <a:rPr lang="en-US" sz="900">
                 <a:solidFill>
                   <a:srgbClr val="5A6875"/>
                 </a:solidFill>
@@ -42218,7 +41793,7 @@
               </a:rPr>
               <a:t>A value that cannot be found word-for-word in the source document fails the run — it is never quietly invented or approximated.</a:t>
             </a:r>
-            <a:endParaRPr lang="en-US" sz="900" dirty="0"/>
+            <a:endParaRPr lang="en-US" sz="900"/>
           </a:p>
         </p:txBody>
       </p:sp>
@@ -42339,7 +41914,7 @@
               <a:buNone/>
             </a:pPr>
             <a:r>
-              <a:rPr lang="en-US" sz="1150" b="1" dirty="0">
+              <a:rPr lang="en-US" sz="1150" b="1">
                 <a:solidFill>
                   <a:srgbClr val="0067B1"/>
                 </a:solidFill>
@@ -42349,7 +41924,7 @@
               </a:rPr>
               <a:t>A named person signs off</a:t>
             </a:r>
-            <a:endParaRPr lang="en-US" sz="1150" dirty="0"/>
+            <a:endParaRPr lang="en-US" sz="1150"/>
           </a:p>
         </p:txBody>
       </p:sp>
@@ -42378,7 +41953,7 @@
               <a:buNone/>
             </a:pPr>
             <a:r>
-              <a:rPr lang="en-US" sz="900" dirty="0">
+              <a:rPr lang="en-US" sz="900">
                 <a:solidFill>
                   <a:srgbClr val="5A6875"/>
                 </a:solidFill>
@@ -42388,7 +41963,7 @@
               </a:rPr>
               <a:t>Each agent stops at a review gate before its output moves on. Decisions are recorded and survive re-runs of the same document.</a:t>
             </a:r>
-            <a:endParaRPr lang="en-US" sz="900" dirty="0"/>
+            <a:endParaRPr lang="en-US" sz="900"/>
           </a:p>
         </p:txBody>
       </p:sp>
@@ -42451,7 +42026,7 @@
               <a:buNone/>
             </a:pPr>
             <a:r>
-              <a:rPr lang="en-US" sz="1050" b="1" dirty="0">
+              <a:rPr lang="en-US" sz="1050" b="1">
                 <a:solidFill>
                   <a:srgbClr val="0067B1"/>
                 </a:solidFill>
@@ -42461,7 +42036,7 @@
               </a:rPr>
               <a:t>Where both agents run</a:t>
             </a:r>
-            <a:endParaRPr lang="en-US" sz="1050" dirty="0"/>
+            <a:endParaRPr lang="en-US" sz="1050"/>
           </a:p>
         </p:txBody>
       </p:sp>
@@ -42490,7 +42065,7 @@
               <a:buNone/>
             </a:pPr>
             <a:r>
-              <a:rPr lang="en-US" sz="950" b="1" dirty="0">
+              <a:rPr lang="en-US" sz="950" b="1">
                 <a:solidFill>
                   <a:srgbClr val="2E3350"/>
                 </a:solidFill>
@@ -42500,7 +42075,7 @@
               </a:rPr>
               <a:t>Lakeflow Declarative Pipelines</a:t>
             </a:r>
-            <a:endParaRPr lang="en-US" sz="950" dirty="0"/>
+            <a:endParaRPr lang="en-US" sz="950"/>
           </a:p>
         </p:txBody>
       </p:sp>
@@ -42529,7 +42104,7 @@
               <a:buNone/>
             </a:pPr>
             <a:r>
-              <a:rPr lang="en-US" sz="800" dirty="0">
+              <a:rPr lang="en-US" sz="800">
                 <a:solidFill>
                   <a:srgbClr val="5A6875"/>
                 </a:solidFill>
@@ -42539,7 +42114,7 @@
               </a:rPr>
               <a:t>one pipeline per agent; each stage re-runnable</a:t>
             </a:r>
-            <a:endParaRPr lang="en-US" sz="800" dirty="0"/>
+            <a:endParaRPr lang="en-US" sz="800"/>
           </a:p>
         </p:txBody>
       </p:sp>
@@ -42568,7 +42143,7 @@
               <a:buNone/>
             </a:pPr>
             <a:r>
-              <a:rPr lang="en-US" sz="950" b="1" dirty="0">
+              <a:rPr lang="en-US" sz="950" b="1">
                 <a:solidFill>
                   <a:srgbClr val="2E3350"/>
                 </a:solidFill>
@@ -42578,7 +42153,7 @@
               </a:rPr>
               <a:t>Unity Catalog</a:t>
             </a:r>
-            <a:endParaRPr lang="en-US" sz="950" dirty="0"/>
+            <a:endParaRPr lang="en-US" sz="950"/>
           </a:p>
         </p:txBody>
       </p:sp>
@@ -42607,7 +42182,7 @@
               <a:buNone/>
             </a:pPr>
             <a:r>
-              <a:rPr lang="en-US" sz="800" dirty="0">
+              <a:rPr lang="en-US" sz="800">
                 <a:solidFill>
                   <a:srgbClr val="5A6875"/>
                 </a:solidFill>
@@ -42617,7 +42192,7 @@
               </a:rPr>
               <a:t>Delta tables and Volumes own every artifact</a:t>
             </a:r>
-            <a:endParaRPr lang="en-US" sz="800" dirty="0"/>
+            <a:endParaRPr lang="en-US" sz="800"/>
           </a:p>
         </p:txBody>
       </p:sp>
@@ -42646,7 +42221,7 @@
               <a:buNone/>
             </a:pPr>
             <a:r>
-              <a:rPr lang="en-US" sz="950" b="1" dirty="0">
+              <a:rPr lang="en-US" sz="950" b="1">
                 <a:solidFill>
                   <a:srgbClr val="2E3350"/>
                 </a:solidFill>
@@ -42656,7 +42231,7 @@
               </a:rPr>
               <a:t>Model Serving / AI Gateway</a:t>
             </a:r>
-            <a:endParaRPr lang="en-US" sz="950" dirty="0"/>
+            <a:endParaRPr lang="en-US" sz="950"/>
           </a:p>
         </p:txBody>
       </p:sp>
@@ -42685,7 +42260,7 @@
               <a:buNone/>
             </a:pPr>
             <a:r>
-              <a:rPr lang="en-US" sz="800" dirty="0">
+              <a:rPr lang="en-US" sz="800">
                 <a:solidFill>
                   <a:srgbClr val="5A6875"/>
                 </a:solidFill>
@@ -42695,7 +42270,7 @@
               </a:rPr>
               <a:t>the Claude-family endpoint each agent calls</a:t>
             </a:r>
-            <a:endParaRPr lang="en-US" sz="800" dirty="0"/>
+            <a:endParaRPr lang="en-US" sz="800"/>
           </a:p>
         </p:txBody>
       </p:sp>
@@ -42724,7 +42299,7 @@
               <a:buNone/>
             </a:pPr>
             <a:r>
-              <a:rPr lang="en-US" sz="950" b="1" dirty="0">
+              <a:rPr lang="en-US" sz="950" b="1">
                 <a:solidFill>
                   <a:srgbClr val="2E3350"/>
                 </a:solidFill>
@@ -42734,7 +42309,7 @@
               </a:rPr>
               <a:t>Databricks Apps</a:t>
             </a:r>
-            <a:endParaRPr lang="en-US" sz="950" dirty="0"/>
+            <a:endParaRPr lang="en-US" sz="950"/>
           </a:p>
         </p:txBody>
       </p:sp>
@@ -42763,7 +42338,7 @@
               <a:buNone/>
             </a:pPr>
             <a:r>
-              <a:rPr lang="en-US" sz="800" dirty="0">
+              <a:rPr lang="en-US" sz="800">
                 <a:solidFill>
                   <a:srgbClr val="5A6875"/>
                 </a:solidFill>
@@ -42773,7 +42348,7 @@
               </a:rPr>
               <a:t>the review surface where a person decides</a:t>
             </a:r>
-            <a:endParaRPr lang="en-US" sz="800" dirty="0"/>
+            <a:endParaRPr lang="en-US" sz="800"/>
           </a:p>
         </p:txBody>
       </p:sp>
@@ -42802,7 +42377,7 @@
               <a:buNone/>
             </a:pPr>
             <a:r>
-              <a:rPr lang="en-US" sz="800" dirty="0">
+              <a:rPr lang="en-US" sz="800">
                 <a:solidFill>
                   <a:srgbClr val="9AA5AE"/>
                 </a:solidFill>
@@ -42812,7 +42387,7 @@
               </a:rPr>
               <a:t>3</a:t>
             </a:r>
-            <a:endParaRPr lang="en-US" sz="800" dirty="0"/>
+            <a:endParaRPr lang="en-US" sz="800"/>
           </a:p>
         </p:txBody>
       </p:sp>
@@ -42891,7 +42466,7 @@
             <a:pPr marL="0" indent="0">
               <a:buNone/>
             </a:pPr>
-            <a:endParaRPr lang="en-US" sz="2000" dirty="0"/>
+            <a:endParaRPr lang="en-US" sz="2000"/>
           </a:p>
         </p:txBody>
       </p:sp>
@@ -42924,7 +42499,7 @@
           <a:lstStyle/>
           <a:p>
             <a:r>
-              <a:rPr lang="en-US" sz="3200" b="1" dirty="0">
+              <a:rPr lang="en-US" sz="3200" b="1">
                 <a:solidFill>
                   <a:schemeClr val="bg1"/>
                 </a:solidFill>
@@ -42932,7 +42507,7 @@
               <a:t>FRD → STTM Agent</a:t>
             </a:r>
             <a:r>
-              <a:rPr lang="en-US" dirty="0">
+              <a:rPr lang="en-US">
                 <a:solidFill>
                   <a:schemeClr val="bg1"/>
                 </a:solidFill>
@@ -43061,7 +42636,7 @@
               <a:buNone/>
             </a:pPr>
             <a:r>
-              <a:rPr lang="en-US" sz="1400" dirty="0">
+              <a:rPr lang="en-US" sz="1400">
                 <a:solidFill>
                   <a:schemeClr val="bg1"/>
                 </a:solidFill>
@@ -43071,7 +42646,7 @@
               </a:rPr>
               <a:t>          One connector layer reaches every source system · the model call runs through Unity AI Gateway · a reviewer approves the draft</a:t>
             </a:r>
-            <a:endParaRPr lang="en-US" sz="1400" dirty="0">
+            <a:endParaRPr lang="en-US" sz="1400">
               <a:solidFill>
                 <a:schemeClr val="bg1"/>
               </a:solidFill>
@@ -44333,7 +43908,7 @@
               <a:buNone/>
             </a:pPr>
             <a:r>
-              <a:rPr lang="en-US" sz="1150" b="1" dirty="0">
+              <a:rPr lang="en-US" sz="1150" b="1">
                 <a:solidFill>
                   <a:srgbClr val="FFFFFF"/>
                 </a:solidFill>
@@ -44343,7 +43918,7 @@
               </a:rPr>
               <a:t>Analyst starts a run</a:t>
             </a:r>
-            <a:endParaRPr lang="en-US" sz="1150" dirty="0"/>
+            <a:endParaRPr lang="en-US" sz="1150"/>
           </a:p>
         </p:txBody>
       </p:sp>
@@ -44378,7 +43953,7 @@
               <a:buNone/>
             </a:pPr>
             <a:r>
-              <a:rPr lang="en-US" sz="850" dirty="0">
+              <a:rPr lang="en-US" sz="850">
                 <a:solidFill>
                   <a:srgbClr val="D4E7FF"/>
                 </a:solidFill>
@@ -44388,7 +43963,7 @@
               </a:rPr>
               <a:t>Databricks review app · confirm-gated</a:t>
             </a:r>
-            <a:endParaRPr lang="en-US" sz="850" dirty="0"/>
+            <a:endParaRPr lang="en-US" sz="850"/>
           </a:p>
         </p:txBody>
       </p:sp>
@@ -44423,7 +43998,7 @@
               <a:buNone/>
             </a:pPr>
             <a:r>
-              <a:rPr lang="en-US" sz="950" b="1" kern="0" spc="120" dirty="0">
+              <a:rPr lang="en-US" sz="950" b="1" kern="0" spc="120">
                 <a:solidFill>
                   <a:srgbClr val="3C2CDA"/>
                 </a:solidFill>
@@ -44433,7 +44008,7 @@
               </a:rPr>
               <a:t>SOURCE SYSTEMS</a:t>
             </a:r>
-            <a:endParaRPr lang="en-US" sz="950" dirty="0"/>
+            <a:endParaRPr lang="en-US" sz="950"/>
           </a:p>
         </p:txBody>
       </p:sp>
@@ -44538,7 +44113,7 @@
               <a:buNone/>
             </a:pPr>
             <a:r>
-              <a:rPr lang="en-US" sz="1050" b="1" dirty="0">
+              <a:rPr lang="en-US" sz="1050" b="1">
                 <a:solidFill>
                   <a:srgbClr val="1A1D2E"/>
                 </a:solidFill>
@@ -44548,7 +44123,7 @@
               </a:rPr>
               <a:t>SharePoint</a:t>
             </a:r>
-            <a:endParaRPr lang="en-US" sz="1050" dirty="0"/>
+            <a:endParaRPr lang="en-US" sz="1050"/>
           </a:p>
         </p:txBody>
       </p:sp>
@@ -44591,7 +44166,7 @@
                 <a:ea typeface="Calibri" pitchFamily="34" charset="-122"/>
                 <a:cs typeface="Calibri" pitchFamily="34" charset="-120"/>
               </a:rPr>
-              <a:t>FRDs and the approved STTM library</a:t>
+              <a:t>FRDs and the approved STTM (for training purpose)</a:t>
             </a:r>
             <a:endParaRPr lang="en-US" sz="760" dirty="0"/>
           </a:p>
@@ -44706,7 +44281,7 @@
                 <a:ea typeface="Calibri" pitchFamily="34" charset="-122"/>
                 <a:cs typeface="Calibri" pitchFamily="34" charset="-120"/>
               </a:rPr>
-              <a:t>Jira board</a:t>
+              <a:t>Jira board/Azure DevOps</a:t>
             </a:r>
             <a:endParaRPr lang="en-US" sz="1050" dirty="0"/>
           </a:p>
@@ -44743,7 +44318,7 @@
               <a:buNone/>
             </a:pPr>
             <a:r>
-              <a:rPr lang="en-US" sz="760" dirty="0">
+              <a:rPr lang="en-US" sz="760">
                 <a:solidFill>
                   <a:srgbClr val="6B7188"/>
                 </a:solidFill>
@@ -44753,7 +44328,7 @@
               </a:rPr>
               <a:t>Requirement stories &amp; acceptance criteria</a:t>
             </a:r>
-            <a:endParaRPr lang="en-US" sz="760" dirty="0"/>
+            <a:endParaRPr lang="en-US" sz="760"/>
           </a:p>
         </p:txBody>
       </p:sp>
@@ -44903,7 +44478,7 @@
               <a:buNone/>
             </a:pPr>
             <a:r>
-              <a:rPr lang="en-US" sz="760" dirty="0">
+              <a:rPr lang="en-US" sz="760">
                 <a:solidFill>
                   <a:srgbClr val="6B7188"/>
                 </a:solidFill>
@@ -44913,7 +44488,7 @@
               </a:rPr>
               <a:t>Extensible — same connector pattern</a:t>
             </a:r>
-            <a:endParaRPr lang="en-US" sz="760" dirty="0"/>
+            <a:endParaRPr lang="en-US" sz="760"/>
           </a:p>
         </p:txBody>
       </p:sp>
@@ -45051,7 +44626,7 @@
               <a:buNone/>
             </a:pPr>
             <a:r>
-              <a:rPr lang="en-US" sz="900" b="1" dirty="0">
+              <a:rPr lang="en-US" sz="900" b="1">
                 <a:solidFill>
                   <a:srgbClr val="07125E"/>
                 </a:solidFill>
@@ -45061,7 +44636,7 @@
               </a:rPr>
               <a:t>Connector layer</a:t>
             </a:r>
-            <a:endParaRPr lang="en-US" sz="900" dirty="0"/>
+            <a:endParaRPr lang="en-US" sz="900"/>
           </a:p>
         </p:txBody>
       </p:sp>
@@ -45096,7 +44671,7 @@
               <a:buNone/>
             </a:pPr>
             <a:r>
-              <a:rPr lang="en-US" sz="720" dirty="0">
+              <a:rPr lang="en-US" sz="720">
                 <a:solidFill>
                   <a:srgbClr val="6B7188"/>
                 </a:solidFill>
@@ -45106,7 +44681,7 @@
               </a:rPr>
               <a:t>MCP services expose each system through one pattern</a:t>
             </a:r>
-            <a:endParaRPr lang="en-US" sz="720" dirty="0"/>
+            <a:endParaRPr lang="en-US" sz="720"/>
           </a:p>
         </p:txBody>
       </p:sp>
@@ -45211,7 +44786,7 @@
               <a:buNone/>
             </a:pPr>
             <a:r>
-              <a:rPr lang="en-US" sz="880" b="1" dirty="0">
+              <a:rPr lang="en-US" sz="880" b="1">
                 <a:solidFill>
                   <a:srgbClr val="1D86FF"/>
                 </a:solidFill>
@@ -45221,7 +44796,7 @@
               </a:rPr>
               <a:t>Auth for every connector</a:t>
             </a:r>
-            <a:endParaRPr lang="en-US" sz="880" dirty="0"/>
+            <a:endParaRPr lang="en-US" sz="880"/>
           </a:p>
         </p:txBody>
       </p:sp>
@@ -45256,7 +44831,7 @@
               <a:buNone/>
             </a:pPr>
             <a:r>
-              <a:rPr lang="en-US" sz="720" dirty="0">
+              <a:rPr lang="en-US" sz="720">
                 <a:solidFill>
                   <a:srgbClr val="6B7188"/>
                 </a:solidFill>
@@ -45266,7 +44841,7 @@
               </a:rPr>
               <a:t>Entra ID app · OAuth · scoped read-only</a:t>
             </a:r>
-            <a:endParaRPr lang="en-US" sz="720" dirty="0"/>
+            <a:endParaRPr lang="en-US" sz="720"/>
           </a:p>
         </p:txBody>
       </p:sp>
@@ -45397,7 +44972,7 @@
               <a:buNone/>
             </a:pPr>
             <a:r>
-              <a:rPr lang="en-US" sz="1350" b="1" dirty="0">
+              <a:rPr lang="en-US" sz="1350" b="1">
                 <a:solidFill>
                   <a:srgbClr val="FFFFFF"/>
                 </a:solidFill>
@@ -45407,7 +44982,7 @@
               </a:rPr>
               <a:t>STTM Agent</a:t>
             </a:r>
-            <a:endParaRPr lang="en-US" sz="1350" dirty="0"/>
+            <a:endParaRPr lang="en-US" sz="1350"/>
           </a:p>
         </p:txBody>
       </p:sp>
@@ -45442,7 +45017,7 @@
               <a:buNone/>
             </a:pPr>
             <a:r>
-              <a:rPr lang="en-US" sz="820" dirty="0">
+              <a:rPr lang="en-US" sz="820">
                 <a:solidFill>
                   <a:srgbClr val="D6D2F7"/>
                 </a:solidFill>
@@ -45452,14 +45027,14 @@
               </a:rPr>
               <a:t>Databricks serverless job</a:t>
             </a:r>
-            <a:endParaRPr lang="en-US" sz="820" dirty="0"/>
+            <a:endParaRPr lang="en-US" sz="820"/>
           </a:p>
           <a:p>
             <a:pPr marL="0" indent="0" algn="ctr">
               <a:buNone/>
             </a:pPr>
             <a:r>
-              <a:rPr lang="en-US" sz="820" dirty="0">
+              <a:rPr lang="en-US" sz="820">
                 <a:solidFill>
                   <a:srgbClr val="D6D2F7"/>
                 </a:solidFill>
@@ -45469,7 +45044,7 @@
               </a:rPr>
               <a:t>four stages · one model call</a:t>
             </a:r>
-            <a:endParaRPr lang="en-US" sz="820" dirty="0"/>
+            <a:endParaRPr lang="en-US" sz="820"/>
           </a:p>
         </p:txBody>
       </p:sp>
@@ -45539,7 +45114,7 @@
               <a:buNone/>
             </a:pPr>
             <a:r>
-              <a:rPr lang="en-US" sz="760" b="1" dirty="0">
+              <a:rPr lang="en-US" sz="760" b="1">
                 <a:solidFill>
                   <a:srgbClr val="07125E"/>
                 </a:solidFill>
@@ -45549,7 +45124,7 @@
               </a:rPr>
               <a:t>Ingest</a:t>
             </a:r>
-            <a:endParaRPr lang="en-US" sz="760" dirty="0"/>
+            <a:endParaRPr lang="en-US" sz="760"/>
           </a:p>
         </p:txBody>
       </p:sp>
@@ -45619,7 +45194,7 @@
               <a:buNone/>
             </a:pPr>
             <a:r>
-              <a:rPr lang="en-US" sz="760" b="1" dirty="0">
+              <a:rPr lang="en-US" sz="760" b="1">
                 <a:solidFill>
                   <a:srgbClr val="07125E"/>
                 </a:solidFill>
@@ -45629,7 +45204,7 @@
               </a:rPr>
               <a:t>Extract</a:t>
             </a:r>
-            <a:endParaRPr lang="en-US" sz="760" dirty="0"/>
+            <a:endParaRPr lang="en-US" sz="760"/>
           </a:p>
         </p:txBody>
       </p:sp>
@@ -45699,7 +45274,7 @@
               <a:buNone/>
             </a:pPr>
             <a:r>
-              <a:rPr lang="en-US" sz="760" b="1" dirty="0">
+              <a:rPr lang="en-US" sz="760" b="1">
                 <a:solidFill>
                   <a:srgbClr val="14CBDE"/>
                 </a:solidFill>
@@ -45709,7 +45284,7 @@
               </a:rPr>
               <a:t>Audit · Gate</a:t>
             </a:r>
-            <a:endParaRPr lang="en-US" sz="760" dirty="0"/>
+            <a:endParaRPr lang="en-US" sz="760"/>
           </a:p>
         </p:txBody>
       </p:sp>
@@ -45779,7 +45354,7 @@
               <a:buNone/>
             </a:pPr>
             <a:r>
-              <a:rPr lang="en-US" sz="760" b="1" dirty="0">
+              <a:rPr lang="en-US" sz="760" b="1">
                 <a:solidFill>
                   <a:srgbClr val="07125E"/>
                 </a:solidFill>
@@ -45789,7 +45364,7 @@
               </a:rPr>
               <a:t>Render</a:t>
             </a:r>
-            <a:endParaRPr lang="en-US" sz="760" dirty="0"/>
+            <a:endParaRPr lang="en-US" sz="760"/>
           </a:p>
         </p:txBody>
       </p:sp>
@@ -45824,7 +45399,7 @@
               <a:buNone/>
             </a:pPr>
             <a:r>
-              <a:rPr lang="en-US" sz="950" b="1" kern="0" spc="120" dirty="0">
+              <a:rPr lang="en-US" sz="950" b="1" kern="0" spc="120">
                 <a:solidFill>
                   <a:srgbClr val="3C2CDA"/>
                 </a:solidFill>
@@ -45834,7 +45409,7 @@
               </a:rPr>
               <a:t>GENERATED  ·  DRAFT</a:t>
             </a:r>
-            <a:endParaRPr lang="en-US" sz="950" dirty="0"/>
+            <a:endParaRPr lang="en-US" sz="950"/>
           </a:p>
         </p:txBody>
       </p:sp>
@@ -45984,7 +45559,7 @@
               <a:buNone/>
             </a:pPr>
             <a:r>
-              <a:rPr lang="en-US" sz="850" dirty="0">
+              <a:rPr lang="en-US" sz="850">
                 <a:solidFill>
                   <a:srgbClr val="6B7188"/>
                 </a:solidFill>
@@ -45994,7 +45569,7 @@
               </a:rPr>
               <a:t>.xlsx · client dialect · open questions flagged</a:t>
             </a:r>
-            <a:endParaRPr lang="en-US" sz="850" dirty="0"/>
+            <a:endParaRPr lang="en-US" sz="850"/>
           </a:p>
         </p:txBody>
       </p:sp>
@@ -46069,7 +45644,7 @@
               <a:buNone/>
             </a:pPr>
             <a:r>
-              <a:rPr lang="en-US" sz="780" b="1" kern="0" spc="110" dirty="0">
+              <a:rPr lang="en-US" sz="780" b="1" kern="0" spc="110">
                 <a:solidFill>
                   <a:srgbClr val="3C2CDA"/>
                 </a:solidFill>
@@ -46079,7 +45654,7 @@
               </a:rPr>
               <a:t>MODEL ACCESS  ·  GOVERNED RUNTIME</a:t>
             </a:r>
-            <a:endParaRPr lang="en-US" sz="780" dirty="0"/>
+            <a:endParaRPr lang="en-US" sz="780"/>
           </a:p>
         </p:txBody>
       </p:sp>
@@ -46212,7 +45787,7 @@
               <a:buNone/>
             </a:pPr>
             <a:r>
-              <a:rPr lang="en-US" sz="950" b="1" dirty="0">
+              <a:rPr lang="en-US" sz="950" b="1">
                 <a:solidFill>
                   <a:srgbClr val="FFFFFF"/>
                 </a:solidFill>
@@ -46222,7 +45797,7 @@
               </a:rPr>
               <a:t>Unity AI Gateway</a:t>
             </a:r>
-            <a:endParaRPr lang="en-US" sz="950" dirty="0"/>
+            <a:endParaRPr lang="en-US" sz="950"/>
           </a:p>
         </p:txBody>
       </p:sp>
@@ -46257,7 +45832,7 @@
               <a:buNone/>
             </a:pPr>
             <a:r>
-              <a:rPr lang="en-US" sz="760" dirty="0">
+              <a:rPr lang="en-US" sz="760">
                 <a:solidFill>
                   <a:srgbClr val="C7CCEA"/>
                 </a:solidFill>
@@ -46267,7 +45842,7 @@
               </a:rPr>
               <a:t>routing · guardrails · rate limits · cost &amp; audit on every call</a:t>
             </a:r>
-            <a:endParaRPr lang="en-US" sz="760" dirty="0"/>
+            <a:endParaRPr lang="en-US" sz="760"/>
           </a:p>
         </p:txBody>
       </p:sp>
@@ -46405,7 +45980,7 @@
               <a:buNone/>
             </a:pPr>
             <a:r>
-              <a:rPr lang="en-US" sz="860" b="1" dirty="0">
+              <a:rPr lang="en-US" sz="860" b="1">
                 <a:solidFill>
                   <a:srgbClr val="1A1D2E"/>
                 </a:solidFill>
@@ -46415,7 +45990,7 @@
               </a:rPr>
               <a:t>Foundation Model APIs</a:t>
             </a:r>
-            <a:endParaRPr lang="en-US" sz="860" dirty="0"/>
+            <a:endParaRPr lang="en-US" sz="860"/>
           </a:p>
         </p:txBody>
       </p:sp>
@@ -46450,7 +46025,7 @@
               <a:buNone/>
             </a:pPr>
             <a:r>
-              <a:rPr lang="en-US" sz="720" dirty="0">
+              <a:rPr lang="en-US" sz="720">
                 <a:solidFill>
                   <a:srgbClr val="6B7188"/>
                 </a:solidFill>
@@ -46460,7 +46035,7 @@
               </a:rPr>
               <a:t>The one model call — pay per token</a:t>
             </a:r>
-            <a:endParaRPr lang="en-US" sz="720" dirty="0"/>
+            <a:endParaRPr lang="en-US" sz="720"/>
           </a:p>
         </p:txBody>
       </p:sp>
@@ -46565,7 +46140,7 @@
               <a:buNone/>
             </a:pPr>
             <a:r>
-              <a:rPr lang="en-US" sz="860" b="1" dirty="0">
+              <a:rPr lang="en-US" sz="860" b="1">
                 <a:solidFill>
                   <a:srgbClr val="1A1D2E"/>
                 </a:solidFill>
@@ -46575,7 +46150,7 @@
               </a:rPr>
               <a:t>Unity Catalog</a:t>
             </a:r>
-            <a:endParaRPr lang="en-US" sz="860" dirty="0"/>
+            <a:endParaRPr lang="en-US" sz="860"/>
           </a:p>
         </p:txBody>
       </p:sp>
@@ -46610,7 +46185,7 @@
               <a:buNone/>
             </a:pPr>
             <a:r>
-              <a:rPr lang="en-US" sz="720" dirty="0">
+              <a:rPr lang="en-US" sz="720">
                 <a:solidFill>
                   <a:srgbClr val="6B7188"/>
                 </a:solidFill>
@@ -46620,7 +46195,7 @@
               </a:rPr>
               <a:t>Corpus · lineage · run history</a:t>
             </a:r>
-            <a:endParaRPr lang="en-US" sz="720" dirty="0"/>
+            <a:endParaRPr lang="en-US" sz="720"/>
           </a:p>
         </p:txBody>
       </p:sp>
@@ -46894,7 +46469,7 @@
               <a:buNone/>
             </a:pPr>
             <a:r>
-              <a:rPr lang="en-US" sz="1200" b="1" dirty="0">
+              <a:rPr lang="en-US" sz="1200" b="1">
                 <a:solidFill>
                   <a:srgbClr val="FFFFFF"/>
                 </a:solidFill>
@@ -46904,7 +46479,7 @@
               </a:rPr>
               <a:t>Human review — the approval gate</a:t>
             </a:r>
-            <a:endParaRPr lang="en-US" sz="1200" dirty="0"/>
+            <a:endParaRPr lang="en-US" sz="1200"/>
           </a:p>
         </p:txBody>
       </p:sp>
@@ -46939,7 +46514,7 @@
               <a:buNone/>
             </a:pPr>
             <a:r>
-              <a:rPr lang="en-US" sz="880" dirty="0">
+              <a:rPr lang="en-US" sz="880">
                 <a:solidFill>
                   <a:srgbClr val="C7CCEA"/>
                 </a:solidFill>
@@ -46949,7 +46524,7 @@
               </a:rPr>
               <a:t>Reviewers resolve flagged questions, edit in Excel, and approve. Nothing moves downstream unapproved.</a:t>
             </a:r>
-            <a:endParaRPr lang="en-US" sz="880" dirty="0"/>
+            <a:endParaRPr lang="en-US" sz="880"/>
           </a:p>
         </p:txBody>
       </p:sp>
@@ -47020,7 +46595,7 @@
               <a:buNone/>
             </a:pPr>
             <a:r>
-              <a:rPr lang="en-US" sz="700" b="1" kern="0" spc="100" dirty="0">
+              <a:rPr lang="en-US" sz="700" b="1" kern="0" spc="100">
                 <a:solidFill>
                   <a:srgbClr val="8890BE"/>
                 </a:solidFill>
@@ -47030,7 +46605,7 @@
               </a:rPr>
               <a:t>ON APPROVAL</a:t>
             </a:r>
-            <a:endParaRPr lang="en-US" sz="700" dirty="0"/>
+            <a:endParaRPr lang="en-US" sz="700"/>
           </a:p>
         </p:txBody>
       </p:sp>
@@ -47095,7 +46670,7 @@
               <a:buNone/>
             </a:pPr>
             <a:r>
-              <a:rPr lang="en-US" sz="860" dirty="0">
+              <a:rPr lang="en-US" sz="860">
                 <a:solidFill>
                   <a:srgbClr val="14CBDE"/>
                 </a:solidFill>
@@ -47105,7 +46680,7 @@
               </a:rPr>
               <a:t>SharePoint — becomes a template for the next run</a:t>
             </a:r>
-            <a:endParaRPr lang="en-US" sz="860" dirty="0"/>
+            <a:endParaRPr lang="en-US" sz="860"/>
           </a:p>
         </p:txBody>
       </p:sp>
@@ -47180,7 +46755,7 @@
               <a:buNone/>
             </a:pPr>
             <a:r>
-              <a:rPr lang="en-US" sz="820" dirty="0">
+              <a:rPr lang="en-US" sz="820">
                 <a:solidFill>
                   <a:srgbClr val="C7CCEA"/>
                 </a:solidFill>
@@ -47190,7 +46765,7 @@
               </a:rPr>
               <a:t> (optional) — publish the approved mapping to the catalog</a:t>
             </a:r>
-            <a:endParaRPr lang="en-US" sz="820" dirty="0"/>
+            <a:endParaRPr lang="en-US" sz="820"/>
           </a:p>
         </p:txBody>
       </p:sp>
@@ -47302,7 +46877,7 @@
           <a:lstStyle/>
           <a:p>
             <a:r>
-              <a:rPr lang="en-US" sz="2400" b="1" dirty="0">
+              <a:rPr lang="en-US" sz="2400" b="1">
                 <a:solidFill>
                   <a:schemeClr val="bg1"/>
                 </a:solidFill>
@@ -47310,7 +46885,7 @@
               <a:t>FRD → STTM Agent</a:t>
             </a:r>
             <a:r>
-              <a:rPr lang="en-US" sz="2400" dirty="0">
+              <a:rPr lang="en-US" sz="2400">
                 <a:solidFill>
                   <a:schemeClr val="bg1"/>
                 </a:solidFill>
@@ -47351,7 +46926,7 @@
               <a:buNone/>
             </a:pPr>
             <a:r>
-              <a:rPr lang="en-US" sz="800" dirty="0">
+              <a:rPr lang="en-US" sz="800">
                 <a:solidFill>
                   <a:srgbClr val="9AA5AE"/>
                 </a:solidFill>
@@ -47361,7 +46936,7 @@
               </a:rPr>
               <a:t>2</a:t>
             </a:r>
-            <a:endParaRPr lang="en-US" sz="800" dirty="0"/>
+            <a:endParaRPr lang="en-US" sz="800"/>
           </a:p>
         </p:txBody>
       </p:sp>
@@ -47680,21 +47255,26 @@
               <a:defRPr/>
             </a:pPr>
             <a:r>
-              <a:rPr kumimoji="0" lang="en-US" sz="2000" b="1" i="0" u="none" strike="noStrike" kern="1200" cap="none" spc="0" normalizeH="0" baseline="0" noProof="0" dirty="0">
-                <a:ln>
-                  <a:noFill/>
-                </a:ln>
+              <a:rPr lang="en-US" sz="2000" b="1" dirty="0" err="1">
                 <a:solidFill>
                   <a:srgbClr val="FFFFFF"/>
                 </a:solidFill>
-                <a:effectLst/>
-                <a:uLnTx/>
-                <a:uFillTx/>
                 <a:latin typeface="Calibri" pitchFamily="34" charset="0"/>
                 <a:ea typeface="Calibri" pitchFamily="34" charset="-122"/>
                 <a:cs typeface="Calibri" pitchFamily="34" charset="-120"/>
               </a:rPr>
-              <a:t>THE PROGRAM AT A GLANCE</a:t>
+              <a:t>CodeGen</a:t>
+            </a:r>
+            <a:r>
+              <a:rPr lang="en-US" sz="2000" b="1" dirty="0">
+                <a:solidFill>
+                  <a:srgbClr val="FFFFFF"/>
+                </a:solidFill>
+                <a:latin typeface="Calibri" pitchFamily="34" charset="0"/>
+                <a:ea typeface="Calibri" pitchFamily="34" charset="-122"/>
+                <a:cs typeface="Calibri" pitchFamily="34" charset="-120"/>
+              </a:rPr>
+              <a:t>/Data Pipeline Agent</a:t>
             </a:r>
             <a:endParaRPr kumimoji="0" lang="en-US" sz="2000" b="0" i="0" u="none" strike="noStrike" kern="1200" cap="none" spc="0" normalizeH="0" baseline="0" noProof="0" dirty="0">
               <a:ln>
@@ -47758,7 +47338,7 @@
               <a:defRPr/>
             </a:pPr>
             <a:r>
-              <a:rPr kumimoji="0" lang="en-US" sz="1500" b="1" i="0" u="none" strike="noStrike" kern="1200" cap="none" spc="0" normalizeH="0" baseline="0" noProof="0" dirty="0">
+              <a:rPr kumimoji="0" lang="en-US" sz="1500" b="1" i="0" u="none" strike="noStrike" kern="1200" cap="none" spc="0" normalizeH="0" baseline="0" noProof="0">
                 <a:ln>
                   <a:noFill/>
                 </a:ln>
@@ -47774,7 +47354,7 @@
               </a:rPr>
               <a:t>Two agents, one relay — from an approved FRD through to generated pipeline code</a:t>
             </a:r>
-            <a:endParaRPr kumimoji="0" lang="en-US" sz="1500" b="0" i="0" u="none" strike="noStrike" kern="1200" cap="none" spc="0" normalizeH="0" baseline="0" noProof="0" dirty="0">
+            <a:endParaRPr kumimoji="0" lang="en-US" sz="1500" b="0" i="0" u="none" strike="noStrike" kern="1200" cap="none" spc="0" normalizeH="0" baseline="0" noProof="0">
               <a:ln>
                 <a:noFill/>
               </a:ln>
@@ -47906,7 +47486,7 @@
               <a:defRPr/>
             </a:pPr>
             <a:r>
-              <a:rPr kumimoji="0" lang="en-US" sz="1250" b="1" i="0" u="none" strike="noStrike" kern="1200" cap="none" spc="0" normalizeH="0" baseline="0" noProof="0" dirty="0">
+              <a:rPr kumimoji="0" lang="en-US" sz="1250" b="1" i="0" u="none" strike="noStrike" kern="1200" cap="none" spc="0" normalizeH="0" baseline="0" noProof="0">
                 <a:ln>
                   <a:noFill/>
                 </a:ln>
@@ -47922,7 +47502,7 @@
               </a:rPr>
               <a:t>STTM</a:t>
             </a:r>
-            <a:endParaRPr kumimoji="0" lang="en-US" sz="1250" b="0" i="0" u="none" strike="noStrike" kern="1200" cap="none" spc="0" normalizeH="0" baseline="0" noProof="0" dirty="0">
+            <a:endParaRPr kumimoji="0" lang="en-US" sz="1250" b="0" i="0" u="none" strike="noStrike" kern="1200" cap="none" spc="0" normalizeH="0" baseline="0" noProof="0">
               <a:ln>
                 <a:noFill/>
               </a:ln>
@@ -48054,7 +47634,7 @@
               <a:defRPr/>
             </a:pPr>
             <a:r>
-              <a:rPr kumimoji="0" lang="en-US" sz="900" b="1" i="0" u="none" strike="noStrike" kern="0" cap="none" spc="100" normalizeH="0" baseline="0" noProof="0" dirty="0">
+              <a:rPr kumimoji="0" lang="en-US" sz="900" b="1" i="0" u="none" strike="noStrike" kern="0" cap="none" spc="100" normalizeH="0" baseline="0" noProof="0">
                 <a:ln>
                   <a:noFill/>
                 </a:ln>
@@ -48070,7 +47650,7 @@
               </a:rPr>
               <a:t>Agent 2</a:t>
             </a:r>
-            <a:endParaRPr kumimoji="0" lang="en-US" sz="900" b="0" i="0" u="none" strike="noStrike" kern="1200" cap="none" spc="0" normalizeH="0" baseline="0" noProof="0" dirty="0">
+            <a:endParaRPr kumimoji="0" lang="en-US" sz="900" b="0" i="0" u="none" strike="noStrike" kern="1200" cap="none" spc="0" normalizeH="0" baseline="0" noProof="0">
               <a:ln>
                 <a:noFill/>
               </a:ln>
@@ -48132,7 +47712,7 @@
               <a:defRPr/>
             </a:pPr>
             <a:r>
-              <a:rPr kumimoji="0" lang="en-US" sz="1500" b="1" i="0" u="none" strike="noStrike" kern="1200" cap="none" spc="0" normalizeH="0" baseline="0" noProof="0" dirty="0">
+              <a:rPr kumimoji="0" lang="en-US" sz="1500" b="1" i="0" u="none" strike="noStrike" kern="1200" cap="none" spc="0" normalizeH="0" baseline="0" noProof="0">
                 <a:ln>
                   <a:noFill/>
                 </a:ln>
@@ -48148,7 +47728,7 @@
               </a:rPr>
               <a:t>CodeGen</a:t>
             </a:r>
-            <a:endParaRPr kumimoji="0" lang="en-US" sz="1500" b="0" i="0" u="none" strike="noStrike" kern="1200" cap="none" spc="0" normalizeH="0" baseline="0" noProof="0" dirty="0">
+            <a:endParaRPr kumimoji="0" lang="en-US" sz="1500" b="0" i="0" u="none" strike="noStrike" kern="1200" cap="none" spc="0" normalizeH="0" baseline="0" noProof="0">
               <a:ln>
                 <a:noFill/>
               </a:ln>
@@ -48280,7 +47860,7 @@
               <a:defRPr/>
             </a:pPr>
             <a:r>
-              <a:rPr kumimoji="0" lang="en-US" sz="800" b="1" i="0" u="none" strike="noStrike" kern="1200" cap="none" spc="0" normalizeH="0" baseline="0" noProof="0" dirty="0">
+              <a:rPr kumimoji="0" lang="en-US" sz="800" b="1" i="0" u="none" strike="noStrike" kern="1200" cap="none" spc="0" normalizeH="0" baseline="0" noProof="0">
                 <a:ln>
                   <a:noFill/>
                 </a:ln>
@@ -48296,7 +47876,7 @@
               </a:rPr>
               <a:t>human gate</a:t>
             </a:r>
-            <a:endParaRPr kumimoji="0" lang="en-US" sz="800" b="0" i="0" u="none" strike="noStrike" kern="1200" cap="none" spc="0" normalizeH="0" baseline="0" noProof="0" dirty="0">
+            <a:endParaRPr kumimoji="0" lang="en-US" sz="800" b="0" i="0" u="none" strike="noStrike" kern="1200" cap="none" spc="0" normalizeH="0" baseline="0" noProof="0">
               <a:ln>
                 <a:noFill/>
               </a:ln>
@@ -48428,7 +48008,7 @@
               <a:defRPr/>
             </a:pPr>
             <a:r>
-              <a:rPr kumimoji="0" lang="en-US" sz="1250" b="1" i="0" u="none" strike="noStrike" kern="1200" cap="none" spc="0" normalizeH="0" baseline="0" noProof="0" dirty="0">
+              <a:rPr kumimoji="0" lang="en-US" sz="1250" b="1" i="0" u="none" strike="noStrike" kern="1200" cap="none" spc="0" normalizeH="0" baseline="0" noProof="0">
                 <a:ln>
                   <a:noFill/>
                 </a:ln>
@@ -48444,7 +48024,7 @@
               </a:rPr>
               <a:t>Pipeline code</a:t>
             </a:r>
-            <a:endParaRPr kumimoji="0" lang="en-US" sz="1250" b="0" i="0" u="none" strike="noStrike" kern="1200" cap="none" spc="0" normalizeH="0" baseline="0" noProof="0" dirty="0">
+            <a:endParaRPr kumimoji="0" lang="en-US" sz="1250" b="0" i="0" u="none" strike="noStrike" kern="1200" cap="none" spc="0" normalizeH="0" baseline="0" noProof="0">
               <a:ln>
                 <a:noFill/>
               </a:ln>
@@ -48506,7 +48086,7 @@
               <a:defRPr/>
             </a:pPr>
             <a:r>
-              <a:rPr kumimoji="0" lang="en-US" sz="900" b="0" i="0" u="none" strike="noStrike" kern="1200" cap="none" spc="0" normalizeH="0" baseline="0" noProof="0" dirty="0">
+              <a:rPr kumimoji="0" lang="en-US" sz="900" b="0" i="0" u="none" strike="noStrike" kern="1200" cap="none" spc="0" normalizeH="0" baseline="0" noProof="0">
                 <a:ln>
                   <a:noFill/>
                 </a:ln>
@@ -48522,7 +48102,7 @@
               </a:rPr>
               <a:t>transforms, DDL,</a:t>
             </a:r>
-            <a:endParaRPr kumimoji="0" lang="en-US" sz="900" b="0" i="0" u="none" strike="noStrike" kern="1200" cap="none" spc="0" normalizeH="0" baseline="0" noProof="0" dirty="0">
+            <a:endParaRPr kumimoji="0" lang="en-US" sz="900" b="0" i="0" u="none" strike="noStrike" kern="1200" cap="none" spc="0" normalizeH="0" baseline="0" noProof="0">
               <a:ln>
                 <a:noFill/>
               </a:ln>
@@ -48556,7 +48136,7 @@
               <a:defRPr/>
             </a:pPr>
             <a:r>
-              <a:rPr kumimoji="0" lang="en-US" sz="900" b="0" i="0" u="none" strike="noStrike" kern="1200" cap="none" spc="0" normalizeH="0" baseline="0" noProof="0" dirty="0">
+              <a:rPr kumimoji="0" lang="en-US" sz="900" b="0" i="0" u="none" strike="noStrike" kern="1200" cap="none" spc="0" normalizeH="0" baseline="0" noProof="0">
                 <a:ln>
                   <a:noFill/>
                 </a:ln>
@@ -48572,7 +48152,7 @@
               </a:rPr>
               <a:t>tests, job config</a:t>
             </a:r>
-            <a:endParaRPr kumimoji="0" lang="en-US" sz="900" b="0" i="0" u="none" strike="noStrike" kern="1200" cap="none" spc="0" normalizeH="0" baseline="0" noProof="0" dirty="0">
+            <a:endParaRPr kumimoji="0" lang="en-US" sz="900" b="0" i="0" u="none" strike="noStrike" kern="1200" cap="none" spc="0" normalizeH="0" baseline="0" noProof="0">
               <a:ln>
                 <a:noFill/>
               </a:ln>
@@ -48634,7 +48214,7 @@
               <a:defRPr/>
             </a:pPr>
             <a:r>
-              <a:rPr kumimoji="0" lang="en-US" sz="1050" b="0" i="1" u="none" strike="noStrike" kern="1200" cap="none" spc="0" normalizeH="0" baseline="0" noProof="0" dirty="0">
+              <a:rPr kumimoji="0" lang="en-US" sz="1050" b="0" i="1" u="none" strike="noStrike" kern="1200" cap="none" spc="0" normalizeH="0" baseline="0" noProof="0">
                 <a:ln>
                   <a:noFill/>
                 </a:ln>
@@ -48650,7 +48230,7 @@
               </a:rPr>
               <a:t>The FRD is authored and approved by your team. Agent 1's workbook is Agent 2's input — and nothing moves downstream until a named person approves it.</a:t>
             </a:r>
-            <a:endParaRPr kumimoji="0" lang="en-US" sz="1050" b="0" i="0" u="none" strike="noStrike" kern="1200" cap="none" spc="0" normalizeH="0" baseline="0" noProof="0" dirty="0">
+            <a:endParaRPr kumimoji="0" lang="en-US" sz="1050" b="0" i="0" u="none" strike="noStrike" kern="1200" cap="none" spc="0" normalizeH="0" baseline="0" noProof="0">
               <a:ln>
                 <a:noFill/>
               </a:ln>
@@ -48712,7 +48292,7 @@
               <a:defRPr/>
             </a:pPr>
             <a:r>
-              <a:rPr kumimoji="0" lang="en-US" sz="1050" b="0" i="1" u="none" strike="noStrike" kern="1200" cap="none" spc="0" normalizeH="0" baseline="0" noProof="0" dirty="0">
+              <a:rPr kumimoji="0" lang="en-US" sz="1050" b="0" i="1" u="none" strike="noStrike" kern="1200" cap="none" spc="0" normalizeH="0" baseline="0" noProof="0">
                 <a:ln>
                   <a:noFill/>
                 </a:ln>
@@ -48728,7 +48308,7 @@
               </a:rPr>
               <a:t>FRDs and STTM workbooks are read from, and written back to, the AmeriHealth SharePoint document library through the Microsoft Graph API.</a:t>
             </a:r>
-            <a:endParaRPr kumimoji="0" lang="en-US" sz="1050" b="0" i="0" u="none" strike="noStrike" kern="1200" cap="none" spc="0" normalizeH="0" baseline="0" noProof="0" dirty="0">
+            <a:endParaRPr kumimoji="0" lang="en-US" sz="1050" b="0" i="0" u="none" strike="noStrike" kern="1200" cap="none" spc="0" normalizeH="0" baseline="0" noProof="0">
               <a:ln>
                 <a:noFill/>
               </a:ln>
@@ -48960,7 +48540,7 @@
               <a:defRPr/>
             </a:pPr>
             <a:r>
-              <a:rPr kumimoji="0" lang="en-US" sz="1150" b="1" i="0" u="none" strike="noStrike" kern="1200" cap="none" spc="0" normalizeH="0" baseline="0" noProof="0" dirty="0">
+              <a:rPr kumimoji="0" lang="en-US" sz="1150" b="1" i="0" u="none" strike="noStrike" kern="1200" cap="none" spc="0" normalizeH="0" baseline="0" noProof="0">
                 <a:ln>
                   <a:noFill/>
                 </a:ln>
@@ -48976,7 +48556,7 @@
               </a:rPr>
               <a:t>The AI only ever drafts</a:t>
             </a:r>
-            <a:endParaRPr kumimoji="0" lang="en-US" sz="1150" b="0" i="0" u="none" strike="noStrike" kern="1200" cap="none" spc="0" normalizeH="0" baseline="0" noProof="0" dirty="0">
+            <a:endParaRPr kumimoji="0" lang="en-US" sz="1150" b="0" i="0" u="none" strike="noStrike" kern="1200" cap="none" spc="0" normalizeH="0" baseline="0" noProof="0">
               <a:ln>
                 <a:noFill/>
               </a:ln>
@@ -49038,7 +48618,7 @@
               <a:defRPr/>
             </a:pPr>
             <a:r>
-              <a:rPr kumimoji="0" lang="en-US" sz="900" b="0" i="0" u="none" strike="noStrike" kern="1200" cap="none" spc="0" normalizeH="0" baseline="0" noProof="0" dirty="0">
+              <a:rPr kumimoji="0" lang="en-US" sz="900" b="0" i="0" u="none" strike="noStrike" kern="1200" cap="none" spc="0" normalizeH="0" baseline="0" noProof="0">
                 <a:ln>
                   <a:noFill/>
                 </a:ln>
@@ -49054,7 +48634,7 @@
               </a:rPr>
               <a:t>Validation, grounding, gating and rendering are all ordinary code. The model is never the arbiter of whether its own output is right.</a:t>
             </a:r>
-            <a:endParaRPr kumimoji="0" lang="en-US" sz="900" b="0" i="0" u="none" strike="noStrike" kern="1200" cap="none" spc="0" normalizeH="0" baseline="0" noProof="0" dirty="0">
+            <a:endParaRPr kumimoji="0" lang="en-US" sz="900" b="0" i="0" u="none" strike="noStrike" kern="1200" cap="none" spc="0" normalizeH="0" baseline="0" noProof="0">
               <a:ln>
                 <a:noFill/>
               </a:ln>
@@ -49286,7 +48866,7 @@
               <a:defRPr/>
             </a:pPr>
             <a:r>
-              <a:rPr kumimoji="0" lang="en-US" sz="1150" b="1" i="0" u="none" strike="noStrike" kern="1200" cap="none" spc="0" normalizeH="0" baseline="0" noProof="0" dirty="0">
+              <a:rPr kumimoji="0" lang="en-US" sz="1150" b="1" i="0" u="none" strike="noStrike" kern="1200" cap="none" spc="0" normalizeH="0" baseline="0" noProof="0">
                 <a:ln>
                   <a:noFill/>
                 </a:ln>
@@ -49303,7 +48883,7 @@
               <a:t>Every </a:t>
             </a:r>
             <a:r>
-              <a:rPr lang="en-US" sz="1150" b="1" dirty="0">
+              <a:rPr lang="en-US" sz="1150" b="1">
                 <a:solidFill>
                   <a:srgbClr val="0067B1"/>
                 </a:solidFill>
@@ -49314,7 +48894,7 @@
               <a:t>outcome</a:t>
             </a:r>
             <a:r>
-              <a:rPr kumimoji="0" lang="en-US" sz="1150" b="1" i="0" u="none" strike="noStrike" kern="1200" cap="none" spc="0" normalizeH="0" baseline="0" noProof="0" dirty="0">
+              <a:rPr kumimoji="0" lang="en-US" sz="1150" b="1" i="0" u="none" strike="noStrike" kern="1200" cap="none" spc="0" normalizeH="0" baseline="0" noProof="0">
                 <a:ln>
                   <a:noFill/>
                 </a:ln>
@@ -49330,7 +48910,7 @@
               </a:rPr>
               <a:t> cites its source</a:t>
             </a:r>
-            <a:endParaRPr kumimoji="0" lang="en-US" sz="1150" b="0" i="0" u="none" strike="noStrike" kern="1200" cap="none" spc="0" normalizeH="0" baseline="0" noProof="0" dirty="0">
+            <a:endParaRPr kumimoji="0" lang="en-US" sz="1150" b="0" i="0" u="none" strike="noStrike" kern="1200" cap="none" spc="0" normalizeH="0" baseline="0" noProof="0">
               <a:ln>
                 <a:noFill/>
               </a:ln>
@@ -49392,7 +48972,7 @@
               <a:defRPr/>
             </a:pPr>
             <a:r>
-              <a:rPr kumimoji="0" lang="en-US" sz="900" b="0" i="0" u="none" strike="noStrike" kern="1200" cap="none" spc="0" normalizeH="0" baseline="0" noProof="0" dirty="0">
+              <a:rPr kumimoji="0" lang="en-US" sz="900" b="0" i="0" u="none" strike="noStrike" kern="1200" cap="none" spc="0" normalizeH="0" baseline="0" noProof="0">
                 <a:ln>
                   <a:noFill/>
                 </a:ln>
@@ -49408,7 +48988,7 @@
               </a:rPr>
               <a:t>A value that cannot be found word-for-word in the source document fails the run — it is never quietly invented or approximated.</a:t>
             </a:r>
-            <a:endParaRPr kumimoji="0" lang="en-US" sz="900" b="0" i="0" u="none" strike="noStrike" kern="1200" cap="none" spc="0" normalizeH="0" baseline="0" noProof="0" dirty="0">
+            <a:endParaRPr kumimoji="0" lang="en-US" sz="900" b="0" i="0" u="none" strike="noStrike" kern="1200" cap="none" spc="0" normalizeH="0" baseline="0" noProof="0">
               <a:ln>
                 <a:noFill/>
               </a:ln>
@@ -49640,7 +49220,7 @@
               <a:defRPr/>
             </a:pPr>
             <a:r>
-              <a:rPr kumimoji="0" lang="en-US" sz="1150" b="1" i="0" u="none" strike="noStrike" kern="1200" cap="none" spc="0" normalizeH="0" baseline="0" noProof="0" dirty="0">
+              <a:rPr kumimoji="0" lang="en-US" sz="1150" b="1" i="0" u="none" strike="noStrike" kern="1200" cap="none" spc="0" normalizeH="0" baseline="0" noProof="0">
                 <a:ln>
                   <a:noFill/>
                 </a:ln>
@@ -49656,7 +49236,7 @@
               </a:rPr>
               <a:t>A named person signs off</a:t>
             </a:r>
-            <a:endParaRPr kumimoji="0" lang="en-US" sz="1150" b="0" i="0" u="none" strike="noStrike" kern="1200" cap="none" spc="0" normalizeH="0" baseline="0" noProof="0" dirty="0">
+            <a:endParaRPr kumimoji="0" lang="en-US" sz="1150" b="0" i="0" u="none" strike="noStrike" kern="1200" cap="none" spc="0" normalizeH="0" baseline="0" noProof="0">
               <a:ln>
                 <a:noFill/>
               </a:ln>
@@ -49718,7 +49298,7 @@
               <a:defRPr/>
             </a:pPr>
             <a:r>
-              <a:rPr kumimoji="0" lang="en-US" sz="900" b="0" i="0" u="none" strike="noStrike" kern="1200" cap="none" spc="0" normalizeH="0" baseline="0" noProof="0" dirty="0">
+              <a:rPr kumimoji="0" lang="en-US" sz="900" b="0" i="0" u="none" strike="noStrike" kern="1200" cap="none" spc="0" normalizeH="0" baseline="0" noProof="0">
                 <a:ln>
                   <a:noFill/>
                 </a:ln>
@@ -49734,7 +49314,7 @@
               </a:rPr>
               <a:t>Each agent stops at a review gate before its output moves on. Decisions are recorded and survive re-runs of the same document.</a:t>
             </a:r>
-            <a:endParaRPr kumimoji="0" lang="en-US" sz="900" b="0" i="0" u="none" strike="noStrike" kern="1200" cap="none" spc="0" normalizeH="0" baseline="0" noProof="0" dirty="0">
+            <a:endParaRPr kumimoji="0" lang="en-US" sz="900" b="0" i="0" u="none" strike="noStrike" kern="1200" cap="none" spc="0" normalizeH="0" baseline="0" noProof="0">
               <a:ln>
                 <a:noFill/>
               </a:ln>
@@ -49866,7 +49446,7 @@
               <a:defRPr/>
             </a:pPr>
             <a:r>
-              <a:rPr kumimoji="0" lang="en-US" sz="1050" b="1" i="0" u="none" strike="noStrike" kern="1200" cap="none" spc="0" normalizeH="0" baseline="0" noProof="0" dirty="0">
+              <a:rPr kumimoji="0" lang="en-US" sz="1050" b="1" i="0" u="none" strike="noStrike" kern="1200" cap="none" spc="0" normalizeH="0" baseline="0" noProof="0">
                 <a:ln>
                   <a:noFill/>
                 </a:ln>
@@ -49882,7 +49462,7 @@
               </a:rPr>
               <a:t>Where both agents run</a:t>
             </a:r>
-            <a:endParaRPr kumimoji="0" lang="en-US" sz="1050" b="0" i="0" u="none" strike="noStrike" kern="1200" cap="none" spc="0" normalizeH="0" baseline="0" noProof="0" dirty="0">
+            <a:endParaRPr kumimoji="0" lang="en-US" sz="1050" b="0" i="0" u="none" strike="noStrike" kern="1200" cap="none" spc="0" normalizeH="0" baseline="0" noProof="0">
               <a:ln>
                 <a:noFill/>
               </a:ln>
@@ -49944,7 +49524,7 @@
               <a:defRPr/>
             </a:pPr>
             <a:r>
-              <a:rPr kumimoji="0" lang="en-US" sz="950" b="1" i="0" u="none" strike="noStrike" kern="1200" cap="none" spc="0" normalizeH="0" baseline="0" noProof="0" dirty="0">
+              <a:rPr kumimoji="0" lang="en-US" sz="950" b="1" i="0" u="none" strike="noStrike" kern="1200" cap="none" spc="0" normalizeH="0" baseline="0" noProof="0">
                 <a:ln>
                   <a:noFill/>
                 </a:ln>
@@ -49960,7 +49540,7 @@
               </a:rPr>
               <a:t>Lakeflow Declarative Pipelines</a:t>
             </a:r>
-            <a:endParaRPr kumimoji="0" lang="en-US" sz="950" b="0" i="0" u="none" strike="noStrike" kern="1200" cap="none" spc="0" normalizeH="0" baseline="0" noProof="0" dirty="0">
+            <a:endParaRPr kumimoji="0" lang="en-US" sz="950" b="0" i="0" u="none" strike="noStrike" kern="1200" cap="none" spc="0" normalizeH="0" baseline="0" noProof="0">
               <a:ln>
                 <a:noFill/>
               </a:ln>
@@ -50022,7 +49602,7 @@
               <a:defRPr/>
             </a:pPr>
             <a:r>
-              <a:rPr kumimoji="0" lang="en-US" sz="800" b="0" i="0" u="none" strike="noStrike" kern="1200" cap="none" spc="0" normalizeH="0" baseline="0" noProof="0" dirty="0">
+              <a:rPr kumimoji="0" lang="en-US" sz="800" b="0" i="0" u="none" strike="noStrike" kern="1200" cap="none" spc="0" normalizeH="0" baseline="0" noProof="0">
                 <a:ln>
                   <a:noFill/>
                 </a:ln>
@@ -50038,7 +49618,7 @@
               </a:rPr>
               <a:t>one pipeline per agent; each stage re-runnable</a:t>
             </a:r>
-            <a:endParaRPr kumimoji="0" lang="en-US" sz="800" b="0" i="0" u="none" strike="noStrike" kern="1200" cap="none" spc="0" normalizeH="0" baseline="0" noProof="0" dirty="0">
+            <a:endParaRPr kumimoji="0" lang="en-US" sz="800" b="0" i="0" u="none" strike="noStrike" kern="1200" cap="none" spc="0" normalizeH="0" baseline="0" noProof="0">
               <a:ln>
                 <a:noFill/>
               </a:ln>
@@ -50100,7 +49680,7 @@
               <a:defRPr/>
             </a:pPr>
             <a:r>
-              <a:rPr kumimoji="0" lang="en-US" sz="950" b="1" i="0" u="none" strike="noStrike" kern="1200" cap="none" spc="0" normalizeH="0" baseline="0" noProof="0" dirty="0">
+              <a:rPr kumimoji="0" lang="en-US" sz="950" b="1" i="0" u="none" strike="noStrike" kern="1200" cap="none" spc="0" normalizeH="0" baseline="0" noProof="0">
                 <a:ln>
                   <a:noFill/>
                 </a:ln>
@@ -50116,7 +49696,7 @@
               </a:rPr>
               <a:t>Unity Catalog</a:t>
             </a:r>
-            <a:endParaRPr kumimoji="0" lang="en-US" sz="950" b="0" i="0" u="none" strike="noStrike" kern="1200" cap="none" spc="0" normalizeH="0" baseline="0" noProof="0" dirty="0">
+            <a:endParaRPr kumimoji="0" lang="en-US" sz="950" b="0" i="0" u="none" strike="noStrike" kern="1200" cap="none" spc="0" normalizeH="0" baseline="0" noProof="0">
               <a:ln>
                 <a:noFill/>
               </a:ln>
@@ -50178,7 +49758,7 @@
               <a:defRPr/>
             </a:pPr>
             <a:r>
-              <a:rPr kumimoji="0" lang="en-US" sz="800" b="0" i="0" u="none" strike="noStrike" kern="1200" cap="none" spc="0" normalizeH="0" baseline="0" noProof="0" dirty="0">
+              <a:rPr kumimoji="0" lang="en-US" sz="800" b="0" i="0" u="none" strike="noStrike" kern="1200" cap="none" spc="0" normalizeH="0" baseline="0" noProof="0">
                 <a:ln>
                   <a:noFill/>
                 </a:ln>
@@ -50194,7 +49774,7 @@
               </a:rPr>
               <a:t>Delta tables and Volumes own every artifact</a:t>
             </a:r>
-            <a:endParaRPr kumimoji="0" lang="en-US" sz="800" b="0" i="0" u="none" strike="noStrike" kern="1200" cap="none" spc="0" normalizeH="0" baseline="0" noProof="0" dirty="0">
+            <a:endParaRPr kumimoji="0" lang="en-US" sz="800" b="0" i="0" u="none" strike="noStrike" kern="1200" cap="none" spc="0" normalizeH="0" baseline="0" noProof="0">
               <a:ln>
                 <a:noFill/>
               </a:ln>
@@ -50256,7 +49836,7 @@
               <a:defRPr/>
             </a:pPr>
             <a:r>
-              <a:rPr kumimoji="0" lang="en-US" sz="950" b="1" i="0" u="none" strike="noStrike" kern="1200" cap="none" spc="0" normalizeH="0" baseline="0" noProof="0" dirty="0">
+              <a:rPr kumimoji="0" lang="en-US" sz="950" b="1" i="0" u="none" strike="noStrike" kern="1200" cap="none" spc="0" normalizeH="0" baseline="0" noProof="0">
                 <a:ln>
                   <a:noFill/>
                 </a:ln>
@@ -50272,7 +49852,7 @@
               </a:rPr>
               <a:t>Model Serving / AI Gateway</a:t>
             </a:r>
-            <a:endParaRPr kumimoji="0" lang="en-US" sz="950" b="0" i="0" u="none" strike="noStrike" kern="1200" cap="none" spc="0" normalizeH="0" baseline="0" noProof="0" dirty="0">
+            <a:endParaRPr kumimoji="0" lang="en-US" sz="950" b="0" i="0" u="none" strike="noStrike" kern="1200" cap="none" spc="0" normalizeH="0" baseline="0" noProof="0">
               <a:ln>
                 <a:noFill/>
               </a:ln>
@@ -50334,7 +49914,7 @@
               <a:defRPr/>
             </a:pPr>
             <a:r>
-              <a:rPr kumimoji="0" lang="en-US" sz="800" b="0" i="0" u="none" strike="noStrike" kern="1200" cap="none" spc="0" normalizeH="0" baseline="0" noProof="0" dirty="0">
+              <a:rPr kumimoji="0" lang="en-US" sz="800" b="0" i="0" u="none" strike="noStrike" kern="1200" cap="none" spc="0" normalizeH="0" baseline="0" noProof="0">
                 <a:ln>
                   <a:noFill/>
                 </a:ln>
@@ -50350,7 +49930,7 @@
               </a:rPr>
               <a:t>the Claude-family endpoint each agent calls</a:t>
             </a:r>
-            <a:endParaRPr kumimoji="0" lang="en-US" sz="800" b="0" i="0" u="none" strike="noStrike" kern="1200" cap="none" spc="0" normalizeH="0" baseline="0" noProof="0" dirty="0">
+            <a:endParaRPr kumimoji="0" lang="en-US" sz="800" b="0" i="0" u="none" strike="noStrike" kern="1200" cap="none" spc="0" normalizeH="0" baseline="0" noProof="0">
               <a:ln>
                 <a:noFill/>
               </a:ln>
@@ -50412,7 +49992,7 @@
               <a:defRPr/>
             </a:pPr>
             <a:r>
-              <a:rPr kumimoji="0" lang="en-US" sz="950" b="1" i="0" u="none" strike="noStrike" kern="1200" cap="none" spc="0" normalizeH="0" baseline="0" noProof="0" dirty="0">
+              <a:rPr kumimoji="0" lang="en-US" sz="950" b="1" i="0" u="none" strike="noStrike" kern="1200" cap="none" spc="0" normalizeH="0" baseline="0" noProof="0">
                 <a:ln>
                   <a:noFill/>
                 </a:ln>
@@ -50428,7 +50008,7 @@
               </a:rPr>
               <a:t>Databricks Apps</a:t>
             </a:r>
-            <a:endParaRPr kumimoji="0" lang="en-US" sz="950" b="0" i="0" u="none" strike="noStrike" kern="1200" cap="none" spc="0" normalizeH="0" baseline="0" noProof="0" dirty="0">
+            <a:endParaRPr kumimoji="0" lang="en-US" sz="950" b="0" i="0" u="none" strike="noStrike" kern="1200" cap="none" spc="0" normalizeH="0" baseline="0" noProof="0">
               <a:ln>
                 <a:noFill/>
               </a:ln>
@@ -50490,7 +50070,7 @@
               <a:defRPr/>
             </a:pPr>
             <a:r>
-              <a:rPr kumimoji="0" lang="en-US" sz="800" b="0" i="0" u="none" strike="noStrike" kern="1200" cap="none" spc="0" normalizeH="0" baseline="0" noProof="0" dirty="0">
+              <a:rPr kumimoji="0" lang="en-US" sz="800" b="0" i="0" u="none" strike="noStrike" kern="1200" cap="none" spc="0" normalizeH="0" baseline="0" noProof="0">
                 <a:ln>
                   <a:noFill/>
                 </a:ln>
@@ -50506,7 +50086,7 @@
               </a:rPr>
               <a:t>the review surface where a person decides</a:t>
             </a:r>
-            <a:endParaRPr kumimoji="0" lang="en-US" sz="800" b="0" i="0" u="none" strike="noStrike" kern="1200" cap="none" spc="0" normalizeH="0" baseline="0" noProof="0" dirty="0">
+            <a:endParaRPr kumimoji="0" lang="en-US" sz="800" b="0" i="0" u="none" strike="noStrike" kern="1200" cap="none" spc="0" normalizeH="0" baseline="0" noProof="0">
               <a:ln>
                 <a:noFill/>
               </a:ln>
@@ -50568,7 +50148,7 @@
               <a:defRPr/>
             </a:pPr>
             <a:r>
-              <a:rPr kumimoji="0" lang="en-US" sz="800" b="0" i="0" u="none" strike="noStrike" kern="1200" cap="none" spc="0" normalizeH="0" baseline="0" noProof="0" dirty="0">
+              <a:rPr kumimoji="0" lang="en-US" sz="800" b="0" i="0" u="none" strike="noStrike" kern="1200" cap="none" spc="0" normalizeH="0" baseline="0" noProof="0">
                 <a:ln>
                   <a:noFill/>
                 </a:ln>
@@ -50584,7 +50164,7 @@
               </a:rPr>
               <a:t>3</a:t>
             </a:r>
-            <a:endParaRPr kumimoji="0" lang="en-US" sz="800" b="0" i="0" u="none" strike="noStrike" kern="1200" cap="none" spc="0" normalizeH="0" baseline="0" noProof="0" dirty="0">
+            <a:endParaRPr kumimoji="0" lang="en-US" sz="800" b="0" i="0" u="none" strike="noStrike" kern="1200" cap="none" spc="0" normalizeH="0" baseline="0" noProof="0">
               <a:ln>
                 <a:noFill/>
               </a:ln>
@@ -51358,6 +50938,12 @@
 </file>
 
 <file path=customXml/item2.xml><?xml version="1.0" encoding="utf-8"?>
+<p:properties xmlns:p="http://schemas.microsoft.com/office/2006/metadata/properties" xmlns:xsi="http://www.w3.org/2001/XMLSchema-instance" xmlns:pc="http://schemas.microsoft.com/office/infopath/2007/PartnerControls">
+  <documentManagement/>
+</p:properties>
+</file>
+
+<file path=customXml/item3.xml><?xml version="1.0" encoding="utf-8"?>
 <ct:contentTypeSchema xmlns:ct="http://schemas.microsoft.com/office/2006/metadata/contentType" xmlns:ma="http://schemas.microsoft.com/office/2006/metadata/properties/metaAttributes" ct:_="" ma:_="" ma:contentTypeName="Document" ma:contentTypeID="0x01010020426B2D8CA0A94F885E990AD9C65561" ma:contentTypeVersion="3" ma:contentTypeDescription="Create a new document." ma:contentTypeScope="" ma:versionID="85bb13b16a9506a223afed9a3ec3a41c">
   <xsd:schema xmlns:xsd="http://www.w3.org/2001/XMLSchema" xmlns:xs="http://www.w3.org/2001/XMLSchema" xmlns:p="http://schemas.microsoft.com/office/2006/metadata/properties" xmlns:ns2="6537d64e-af8a-45f1-9663-213a80cc8430" targetNamespace="http://schemas.microsoft.com/office/2006/metadata/properties" ma:root="true" ma:fieldsID="d0025840606445d7475e5c4ef7c05746" ns2:_="">
     <xsd:import namespace="6537d64e-af8a-45f1-9663-213a80cc8430"/>
@@ -51495,12 +51081,6 @@
 </ct:contentTypeSchema>
 </file>
 
-<file path=customXml/item3.xml><?xml version="1.0" encoding="utf-8"?>
-<p:properties xmlns:p="http://schemas.microsoft.com/office/2006/metadata/properties" xmlns:xsi="http://www.w3.org/2001/XMLSchema-instance" xmlns:pc="http://schemas.microsoft.com/office/infopath/2007/PartnerControls">
-  <documentManagement/>
-</p:properties>
-</file>
-
 <file path=customXml/itemProps1.xml><?xml version="1.0" encoding="utf-8"?>
 <ds:datastoreItem xmlns:ds="http://schemas.openxmlformats.org/officeDocument/2006/customXml" ds:itemID="{DDCDE733-B052-48C7-8D8B-6A197F3D689F}">
   <ds:schemaRefs>
@@ -51510,35 +51090,35 @@
 </file>
 
 <file path=customXml/itemProps2.xml><?xml version="1.0" encoding="utf-8"?>
-<ds:datastoreItem xmlns:ds="http://schemas.openxmlformats.org/officeDocument/2006/customXml" ds:itemID="{AB3666F2-4465-4862-A672-AF211D658BD9}">
+<ds:datastoreItem xmlns:ds="http://schemas.openxmlformats.org/officeDocument/2006/customXml" ds:itemID="{3E95DF1D-B647-411E-A3C7-BB819E8DE7D6}">
   <ds:schemaRefs>
-    <ds:schemaRef ds:uri="http://schemas.microsoft.com/office/2006/metadata/contentType"/>
-    <ds:schemaRef ds:uri="http://schemas.microsoft.com/office/2006/metadata/properties/metaAttributes"/>
-    <ds:schemaRef ds:uri="http://www.w3.org/2001/XMLSchema"/>
+    <ds:schemaRef ds:uri="http://schemas.microsoft.com/office/2006/documentManagement/types"/>
+    <ds:schemaRef ds:uri="http://www.w3.org/XML/1998/namespace"/>
+    <ds:schemaRef ds:uri="http://purl.org/dc/elements/1.1/"/>
+    <ds:schemaRef ds:uri="http://schemas.microsoft.com/office/infopath/2007/PartnerControls"/>
+    <ds:schemaRef ds:uri="http://purl.org/dc/dcmitype/"/>
     <ds:schemaRef ds:uri="http://schemas.microsoft.com/office/2006/metadata/properties"/>
+    <ds:schemaRef ds:uri="http://purl.org/dc/terms/"/>
+    <ds:schemaRef ds:uri="http://schemas.openxmlformats.org/package/2006/metadata/core-properties"/>
     <ds:schemaRef ds:uri="6537d64e-af8a-45f1-9663-213a80cc8430"/>
-    <ds:schemaRef ds:uri="http://schemas.microsoft.com/office/2006/documentManagement/types"/>
-    <ds:schemaRef ds:uri="http://schemas.microsoft.com/office/infopath/2007/PartnerControls"/>
-    <ds:schemaRef ds:uri="http://schemas.openxmlformats.org/package/2006/metadata/core-properties"/>
-    <ds:schemaRef ds:uri="http://purl.org/dc/elements/1.1/"/>
-    <ds:schemaRef ds:uri="http://purl.org/dc/terms/"/>
-    <ds:schemaRef ds:uri="http://schemas.microsoft.com/internal/obd"/>
   </ds:schemaRefs>
 </ds:datastoreItem>
 </file>
 
 <file path=customXml/itemProps3.xml><?xml version="1.0" encoding="utf-8"?>
-<ds:datastoreItem xmlns:ds="http://schemas.openxmlformats.org/officeDocument/2006/customXml" ds:itemID="{3E95DF1D-B647-411E-A3C7-BB819E8DE7D6}">
+<ds:datastoreItem xmlns:ds="http://schemas.openxmlformats.org/officeDocument/2006/customXml" ds:itemID="{AB3666F2-4465-4862-A672-AF211D658BD9}">
   <ds:schemaRefs>
+    <ds:schemaRef ds:uri="6537d64e-af8a-45f1-9663-213a80cc8430"/>
+    <ds:schemaRef ds:uri="http://purl.org/dc/elements/1.1/"/>
+    <ds:schemaRef ds:uri="http://purl.org/dc/terms/"/>
+    <ds:schemaRef ds:uri="http://schemas.microsoft.com/internal/obd"/>
+    <ds:schemaRef ds:uri="http://schemas.microsoft.com/office/2006/documentManagement/types"/>
+    <ds:schemaRef ds:uri="http://schemas.microsoft.com/office/2006/metadata/contentType"/>
     <ds:schemaRef ds:uri="http://schemas.microsoft.com/office/2006/metadata/properties"/>
-    <ds:schemaRef ds:uri="http://schemas.microsoft.com/office/2006/documentManagement/types"/>
-    <ds:schemaRef ds:uri="http://purl.org/dc/terms/"/>
-    <ds:schemaRef ds:uri="http://purl.org/dc/elements/1.1/"/>
+    <ds:schemaRef ds:uri="http://schemas.microsoft.com/office/2006/metadata/properties/metaAttributes"/>
     <ds:schemaRef ds:uri="http://schemas.microsoft.com/office/infopath/2007/PartnerControls"/>
     <ds:schemaRef ds:uri="http://schemas.openxmlformats.org/package/2006/metadata/core-properties"/>
-    <ds:schemaRef ds:uri="http://www.w3.org/XML/1998/namespace"/>
-    <ds:schemaRef ds:uri="6537d64e-af8a-45f1-9663-213a80cc8430"/>
-    <ds:schemaRef ds:uri="http://purl.org/dc/dcmitype/"/>
+    <ds:schemaRef ds:uri="http://www.w3.org/2001/XMLSchema"/>
   </ds:schemaRefs>
 </ds:datastoreItem>
 </file>
</xml_diff>